<commit_message>
fix: improve intellectual merits diagram readability across final artifacts
</commit_message>
<xml_diff>
--- a/poster/final-poster.pptx
+++ b/poster/final-poster.pptx
@@ -2,13 +2,13 @@
 <file path=ppt/presentation.xml><?xml version="1.0" encoding="utf-8"?>
 <p:presentation xmlns:p="http://schemas.openxmlformats.org/presentationml/2006/main">
   <p:sldMasterIdLst>
-    <p:sldMasterId xmlns:r="http://schemas.openxmlformats.org/officeDocument/2006/relationships" id="2147483648" r:id="R939d3e1c36b34111"/>
+    <p:sldMasterId xmlns:r="http://schemas.openxmlformats.org/officeDocument/2006/relationships" id="2147483648" r:id="R9b84fa2a82834b80"/>
   </p:sldMasterIdLst>
   <p:notesMasterIdLst>
-    <p:notesMasterId xmlns:r="http://schemas.openxmlformats.org/officeDocument/2006/relationships" r:id="R1bac375d54784d7e"/>
+    <p:notesMasterId xmlns:r="http://schemas.openxmlformats.org/officeDocument/2006/relationships" r:id="Ree80a3ffe55b4eae"/>
   </p:notesMasterIdLst>
   <p:sldIdLst>
-    <p:sldId xmlns:r="http://schemas.openxmlformats.org/officeDocument/2006/relationships" id="256" r:id="R25dbbddbdf4b48ca"/>
+    <p:sldId xmlns:r="http://schemas.openxmlformats.org/officeDocument/2006/relationships" id="256" r:id="R9a4335d6489f414d"/>
   </p:sldIdLst>
   <p:sldSz cx="42804000" cy="30276000"/>
   <p:notesSz cx="6858000" cy="9144000"/>
@@ -510,7 +510,7 @@
   </p:cSld>
   <p:clrMap bg1="lt1" tx1="dk1" bg2="lt2" tx2="dk2" accent1="accent1" accent2="accent2" accent3="accent3" accent4="accent4" accent5="accent5" accent6="accent6" hlink="hlink" folHlink="folHlink"/>
   <p:sldLayoutIdLst>
-    <p:sldLayoutId xmlns:r="http://schemas.openxmlformats.org/officeDocument/2006/relationships" id="2147483649" r:id="R9e0d0f06a9744124"/>
+    <p:sldLayoutId xmlns:r="http://schemas.openxmlformats.org/officeDocument/2006/relationships" id="2147483649" r:id="R3733ee969b7e41c5"/>
   </p:sldLayoutIdLst>
   <p:txStyles>
     <p:titleStyle>
@@ -1423,7 +1423,7 @@
           <p:cNvPr id="58" name="">
             <a:extLst xmlns:a="http://schemas.openxmlformats.org/drawingml/2006/main">
               <a:ext uri="{FF2B5EF4-FFF2-40B4-BE49-F238E27FC236}">
-                <a16:creationId xmlns:a16="http://schemas.microsoft.com/office/drawing/2014/main" id="{CC7065D7-216B-4DE1-AE1D-DAC61FCBEF5B}"/>
+                <a16:creationId xmlns:a16="http://schemas.microsoft.com/office/drawing/2014/main" id="{63DF02A6-BA45-4967-B034-CAEB15B1EC3A}"/>
               </a:ext>
             </a:extLst>
           </p:cNvPr>
@@ -1433,7 +1433,7 @@
           <p:nvPr/>
         </p:nvPicPr>
         <p:blipFill>
-          <a:blip xmlns:r="http://schemas.openxmlformats.org/officeDocument/2006/relationships" xmlns:a="http://schemas.openxmlformats.org/drawingml/2006/main" r:embed="R119450c58714412e"/>
+          <a:blip xmlns:r="http://schemas.openxmlformats.org/officeDocument/2006/relationships" xmlns:a="http://schemas.openxmlformats.org/drawingml/2006/main" r:embed="Rb882faf5a7ef4d88"/>
           <a:stretch xmlns:a="http://schemas.openxmlformats.org/drawingml/2006/main"/>
         </p:blipFill>
         <p:spPr>
@@ -4243,7 +4243,7 @@
           <p:cNvPr id="59" name="">
             <a:extLst xmlns:a="http://schemas.openxmlformats.org/drawingml/2006/main">
               <a:ext uri="{FF2B5EF4-FFF2-40B4-BE49-F238E27FC236}">
-                <a16:creationId xmlns:a16="http://schemas.microsoft.com/office/drawing/2014/main" id="{F2B6D808-CE39-46B9-BBE9-543ED70D8307}"/>
+                <a16:creationId xmlns:a16="http://schemas.microsoft.com/office/drawing/2014/main" id="{6C6CC7FF-1699-4F15-947E-BF5682BC4C8C}"/>
               </a:ext>
             </a:extLst>
           </p:cNvPr>
@@ -4253,13 +4253,13 @@
           <p:nvPr/>
         </p:nvPicPr>
         <p:blipFill>
-          <a:blip xmlns:r="http://schemas.openxmlformats.org/officeDocument/2006/relationships" xmlns:a="http://schemas.openxmlformats.org/drawingml/2006/main" r:embed="R9a853d835fbc4aca"/>
+          <a:blip xmlns:r="http://schemas.openxmlformats.org/officeDocument/2006/relationships" xmlns:a="http://schemas.openxmlformats.org/drawingml/2006/main" r:embed="Rf84def3742b94c92"/>
           <a:stretch xmlns:a="http://schemas.openxmlformats.org/drawingml/2006/main"/>
         </p:blipFill>
         <p:spPr>
           <a:xfrm xmlns:a="http://schemas.openxmlformats.org/drawingml/2006/main">
-            <a:off x="17423342" y="11239500"/>
-            <a:ext cx="7958667" cy="4476750"/>
+            <a:off x="13677572" y="11144250"/>
+            <a:ext cx="15450207" cy="4667250"/>
           </a:xfrm>
           <a:prstGeom xmlns:a="http://schemas.openxmlformats.org/drawingml/2006/main" prst="rect">
             <a:avLst/>
@@ -4271,7 +4271,7 @@
           <p:cNvPr id="61" name="">
             <a:extLst xmlns:a="http://schemas.openxmlformats.org/drawingml/2006/main">
               <a:ext uri="{FF2B5EF4-FFF2-40B4-BE49-F238E27FC236}">
-                <a16:creationId xmlns:a16="http://schemas.microsoft.com/office/drawing/2014/main" id="{605BC589-C514-414B-B69B-ED6B0F196A6E}"/>
+                <a16:creationId xmlns:a16="http://schemas.microsoft.com/office/drawing/2014/main" id="{DE895FD6-40EC-4200-8E86-62F7C8D35119}"/>
               </a:ext>
             </a:extLst>
           </p:cNvPr>
@@ -4281,7 +4281,7 @@
           <p:nvPr/>
         </p:nvPicPr>
         <p:blipFill>
-          <a:blip xmlns:r="http://schemas.openxmlformats.org/officeDocument/2006/relationships" xmlns:a="http://schemas.openxmlformats.org/drawingml/2006/main" r:embed="R0201a133d1204666"/>
+          <a:blip xmlns:r="http://schemas.openxmlformats.org/officeDocument/2006/relationships" xmlns:a="http://schemas.openxmlformats.org/drawingml/2006/main" r:embed="Re34c04a845674878"/>
           <a:stretch xmlns:a="http://schemas.openxmlformats.org/drawingml/2006/main"/>
         </p:blipFill>
         <p:spPr>
@@ -4299,7 +4299,7 @@
           <p:cNvPr id="62" name="">
             <a:extLst xmlns:a="http://schemas.openxmlformats.org/drawingml/2006/main">
               <a:ext uri="{FF2B5EF4-FFF2-40B4-BE49-F238E27FC236}">
-                <a16:creationId xmlns:a16="http://schemas.microsoft.com/office/drawing/2014/main" id="{7CA03783-CAEF-46B9-836B-C79A30A6A6C3}"/>
+                <a16:creationId xmlns:a16="http://schemas.microsoft.com/office/drawing/2014/main" id="{020A0FC6-858E-4703-9338-33B21C210C70}"/>
               </a:ext>
             </a:extLst>
           </p:cNvPr>
@@ -4309,7 +4309,7 @@
           <p:nvPr/>
         </p:nvPicPr>
         <p:blipFill>
-          <a:blip xmlns:r="http://schemas.openxmlformats.org/officeDocument/2006/relationships" xmlns:a="http://schemas.openxmlformats.org/drawingml/2006/main" r:embed="R1c1fe2d2494e41d2"/>
+          <a:blip xmlns:r="http://schemas.openxmlformats.org/officeDocument/2006/relationships" xmlns:a="http://schemas.openxmlformats.org/drawingml/2006/main" r:embed="R80ab41f6929c427e"/>
           <a:stretch xmlns:a="http://schemas.openxmlformats.org/drawingml/2006/main"/>
         </p:blipFill>
         <p:spPr>
@@ -4327,7 +4327,7 @@
           <p:cNvPr id="63" name="">
             <a:extLst xmlns:a="http://schemas.openxmlformats.org/drawingml/2006/main">
               <a:ext uri="{FF2B5EF4-FFF2-40B4-BE49-F238E27FC236}">
-                <a16:creationId xmlns:a16="http://schemas.microsoft.com/office/drawing/2014/main" id="{5CC217F8-67EA-46C3-BA87-9ED5F9E7D453}"/>
+                <a16:creationId xmlns:a16="http://schemas.microsoft.com/office/drawing/2014/main" id="{7664871F-787C-47F4-99AB-606432105483}"/>
               </a:ext>
             </a:extLst>
           </p:cNvPr>
@@ -4337,7 +4337,7 @@
           <p:nvPr/>
         </p:nvPicPr>
         <p:blipFill>
-          <a:blip xmlns:r="http://schemas.openxmlformats.org/officeDocument/2006/relationships" xmlns:a="http://schemas.openxmlformats.org/drawingml/2006/main" r:embed="R0afb4f0a8d8b421b"/>
+          <a:blip xmlns:r="http://schemas.openxmlformats.org/officeDocument/2006/relationships" xmlns:a="http://schemas.openxmlformats.org/drawingml/2006/main" r:embed="R162c5221418347ae"/>
           <a:stretch xmlns:a="http://schemas.openxmlformats.org/drawingml/2006/main"/>
         </p:blipFill>
         <p:spPr>
@@ -4355,7 +4355,7 @@
           <p:cNvPr id="64" name="">
             <a:extLst xmlns:a="http://schemas.openxmlformats.org/drawingml/2006/main">
               <a:ext uri="{FF2B5EF4-FFF2-40B4-BE49-F238E27FC236}">
-                <a16:creationId xmlns:a16="http://schemas.microsoft.com/office/drawing/2014/main" id="{B2B2E789-CCAC-4DF1-8AFB-D6D84725D6A5}"/>
+                <a16:creationId xmlns:a16="http://schemas.microsoft.com/office/drawing/2014/main" id="{4D67A49A-46D6-4D6A-91E2-EC7AE3B9EFB0}"/>
               </a:ext>
             </a:extLst>
           </p:cNvPr>
@@ -4365,7 +4365,7 @@
           <p:nvPr/>
         </p:nvPicPr>
         <p:blipFill>
-          <a:blip xmlns:r="http://schemas.openxmlformats.org/officeDocument/2006/relationships" xmlns:a="http://schemas.openxmlformats.org/drawingml/2006/main" r:embed="R0ffbeacae4034609"/>
+          <a:blip xmlns:r="http://schemas.openxmlformats.org/officeDocument/2006/relationships" xmlns:a="http://schemas.openxmlformats.org/drawingml/2006/main" r:embed="R9aff81d92c574c23"/>
           <a:stretch xmlns:a="http://schemas.openxmlformats.org/drawingml/2006/main"/>
         </p:blipFill>
         <p:spPr>
@@ -4383,7 +4383,7 @@
           <p:cNvPr id="65" name="">
             <a:extLst xmlns:a="http://schemas.openxmlformats.org/drawingml/2006/main">
               <a:ext uri="{FF2B5EF4-FFF2-40B4-BE49-F238E27FC236}">
-                <a16:creationId xmlns:a16="http://schemas.microsoft.com/office/drawing/2014/main" id="{78599B60-D089-455F-B16D-8F5D1FA0541A}"/>
+                <a16:creationId xmlns:a16="http://schemas.microsoft.com/office/drawing/2014/main" id="{83C5D2E9-C42D-4171-BFAD-BE57C976F075}"/>
               </a:ext>
             </a:extLst>
           </p:cNvPr>
@@ -4393,7 +4393,7 @@
           <p:nvPr/>
         </p:nvPicPr>
         <p:blipFill>
-          <a:blip xmlns:r="http://schemas.openxmlformats.org/officeDocument/2006/relationships" xmlns:a="http://schemas.openxmlformats.org/drawingml/2006/main" r:embed="R51514d9923ae4f7f"/>
+          <a:blip xmlns:r="http://schemas.openxmlformats.org/officeDocument/2006/relationships" xmlns:a="http://schemas.openxmlformats.org/drawingml/2006/main" r:embed="Raf263ad0289648c5"/>
           <a:stretch xmlns:a="http://schemas.openxmlformats.org/drawingml/2006/main"/>
         </p:blipFill>
         <p:spPr>
@@ -4411,7 +4411,7 @@
           <p:cNvPr id="66" name="">
             <a:extLst xmlns:a="http://schemas.openxmlformats.org/drawingml/2006/main">
               <a:ext uri="{FF2B5EF4-FFF2-40B4-BE49-F238E27FC236}">
-                <a16:creationId xmlns:a16="http://schemas.microsoft.com/office/drawing/2014/main" id="{CC36D833-B549-430B-B070-B3F40CB86374}"/>
+                <a16:creationId xmlns:a16="http://schemas.microsoft.com/office/drawing/2014/main" id="{D10FD903-DBA1-45A6-822A-090F9BA36202}"/>
               </a:ext>
             </a:extLst>
           </p:cNvPr>
@@ -4475,7 +4475,7 @@
           <p:cNvPr id="67" name="">
             <a:extLst xmlns:a="http://schemas.openxmlformats.org/drawingml/2006/main">
               <a:ext uri="{FF2B5EF4-FFF2-40B4-BE49-F238E27FC236}">
-                <a16:creationId xmlns:a16="http://schemas.microsoft.com/office/drawing/2014/main" id="{DF51A2F7-A1A8-42AF-8EFA-44F0C17E1321}"/>
+                <a16:creationId xmlns:a16="http://schemas.microsoft.com/office/drawing/2014/main" id="{CBC81A1B-00C0-44B1-A77B-740B6E2C7008}"/>
               </a:ext>
             </a:extLst>
           </p:cNvPr>
@@ -4539,7 +4539,7 @@
           <p:cNvPr id="68" name="">
             <a:extLst xmlns:a="http://schemas.openxmlformats.org/drawingml/2006/main">
               <a:ext uri="{FF2B5EF4-FFF2-40B4-BE49-F238E27FC236}">
-                <a16:creationId xmlns:a16="http://schemas.microsoft.com/office/drawing/2014/main" id="{5B429CAD-7C0F-4283-917D-5D8EDC01A933}"/>
+                <a16:creationId xmlns:a16="http://schemas.microsoft.com/office/drawing/2014/main" id="{FA5265B2-BD04-45FB-80A1-5126B0ECFA28}"/>
               </a:ext>
             </a:extLst>
           </p:cNvPr>
@@ -4603,7 +4603,7 @@
           <p:cNvPr id="69" name="">
             <a:extLst xmlns:a="http://schemas.openxmlformats.org/drawingml/2006/main">
               <a:ext uri="{FF2B5EF4-FFF2-40B4-BE49-F238E27FC236}">
-                <a16:creationId xmlns:a16="http://schemas.microsoft.com/office/drawing/2014/main" id="{EFC25209-98C7-4A7E-B043-7673837A071B}"/>
+                <a16:creationId xmlns:a16="http://schemas.microsoft.com/office/drawing/2014/main" id="{56CB8401-4BE7-4791-B02B-007BF43A60A4}"/>
               </a:ext>
             </a:extLst>
           </p:cNvPr>

</xml_diff>

<commit_message>
fix: rebalance final poster layout for section readability
</commit_message>
<xml_diff>
--- a/poster/final-poster.pptx
+++ b/poster/final-poster.pptx
@@ -2,13 +2,13 @@
 <file path=ppt/presentation.xml><?xml version="1.0" encoding="utf-8"?>
 <p:presentation xmlns:p="http://schemas.openxmlformats.org/presentationml/2006/main">
   <p:sldMasterIdLst>
-    <p:sldMasterId xmlns:r="http://schemas.openxmlformats.org/officeDocument/2006/relationships" id="2147483648" r:id="R9b84fa2a82834b80"/>
+    <p:sldMasterId xmlns:r="http://schemas.openxmlformats.org/officeDocument/2006/relationships" id="2147483648" r:id="R4501415a48d7460a"/>
   </p:sldMasterIdLst>
   <p:notesMasterIdLst>
-    <p:notesMasterId xmlns:r="http://schemas.openxmlformats.org/officeDocument/2006/relationships" r:id="Ree80a3ffe55b4eae"/>
+    <p:notesMasterId xmlns:r="http://schemas.openxmlformats.org/officeDocument/2006/relationships" r:id="R41ec0170ae704040"/>
   </p:notesMasterIdLst>
   <p:sldIdLst>
-    <p:sldId xmlns:r="http://schemas.openxmlformats.org/officeDocument/2006/relationships" id="256" r:id="R9a4335d6489f414d"/>
+    <p:sldId xmlns:r="http://schemas.openxmlformats.org/officeDocument/2006/relationships" id="256" r:id="Rf6334f3ef7604858"/>
   </p:sldIdLst>
   <p:sldSz cx="42804000" cy="30276000"/>
   <p:notesSz cx="6858000" cy="9144000"/>
@@ -510,7 +510,7 @@
   </p:cSld>
   <p:clrMap bg1="lt1" tx1="dk1" bg2="lt2" tx2="dk2" accent1="accent1" accent2="accent2" accent3="accent3" accent4="accent4" accent5="accent5" accent6="accent6" hlink="hlink" folHlink="folHlink"/>
   <p:sldLayoutIdLst>
-    <p:sldLayoutId xmlns:r="http://schemas.openxmlformats.org/officeDocument/2006/relationships" id="2147483649" r:id="R3733ee969b7e41c5"/>
+    <p:sldLayoutId xmlns:r="http://schemas.openxmlformats.org/officeDocument/2006/relationships" id="2147483649" r:id="Rb4380da22b064cb9"/>
   </p:sldLayoutIdLst>
   <p:txStyles>
     <p:titleStyle>
@@ -1423,7 +1423,7 @@
           <p:cNvPr id="58" name="">
             <a:extLst xmlns:a="http://schemas.openxmlformats.org/drawingml/2006/main">
               <a:ext uri="{FF2B5EF4-FFF2-40B4-BE49-F238E27FC236}">
-                <a16:creationId xmlns:a16="http://schemas.microsoft.com/office/drawing/2014/main" id="{63DF02A6-BA45-4967-B034-CAEB15B1EC3A}"/>
+                <a16:creationId xmlns:a16="http://schemas.microsoft.com/office/drawing/2014/main" id="{3ABC98D8-729C-44F7-A80B-78D13D8305CE}"/>
               </a:ext>
             </a:extLst>
           </p:cNvPr>
@@ -1433,7 +1433,7 @@
           <p:nvPr/>
         </p:nvPicPr>
         <p:blipFill>
-          <a:blip xmlns:r="http://schemas.openxmlformats.org/officeDocument/2006/relationships" xmlns:a="http://schemas.openxmlformats.org/drawingml/2006/main" r:embed="Rb882faf5a7ef4d88"/>
+          <a:blip xmlns:r="http://schemas.openxmlformats.org/officeDocument/2006/relationships" xmlns:a="http://schemas.openxmlformats.org/drawingml/2006/main" r:embed="R318832318d9e4251"/>
           <a:stretch xmlns:a="http://schemas.openxmlformats.org/drawingml/2006/main"/>
         </p:blipFill>
         <p:spPr>
@@ -1616,7 +1616,7 @@
         <p:spPr>
           <a:xfrm xmlns:a="http://schemas.openxmlformats.org/drawingml/2006/main">
             <a:off x="1333500" y="9525000"/>
-            <a:ext cx="11049000" cy="809625"/>
+            <a:ext cx="10287000" cy="809625"/>
           </a:xfrm>
           <a:prstGeom xmlns:a="http://schemas.openxmlformats.org/drawingml/2006/main" prst="rect">
             <a:avLst/>
@@ -1675,7 +1675,7 @@
         <p:spPr>
           <a:xfrm xmlns:a="http://schemas.openxmlformats.org/drawingml/2006/main">
             <a:off x="1333500" y="10506075"/>
-            <a:ext cx="11049000" cy="47625"/>
+            <a:ext cx="10287000" cy="47625"/>
           </a:xfrm>
           <a:prstGeom xmlns:a="http://schemas.openxmlformats.org/drawingml/2006/main" prst="rect">
             <a:avLst/>
@@ -1706,7 +1706,7 @@
         <p:spPr>
           <a:xfrm xmlns:a="http://schemas.openxmlformats.org/drawingml/2006/main">
             <a:off x="1333500" y="11144250"/>
-            <a:ext cx="11049000" cy="666750"/>
+            <a:ext cx="10287000" cy="666750"/>
           </a:xfrm>
           <a:prstGeom xmlns:a="http://schemas.openxmlformats.org/drawingml/2006/main" prst="rect">
             <a:avLst/>
@@ -1765,7 +1765,7 @@
         <p:spPr>
           <a:xfrm xmlns:a="http://schemas.openxmlformats.org/drawingml/2006/main">
             <a:off x="1333500" y="11906250"/>
-            <a:ext cx="11049000" cy="2952750"/>
+            <a:ext cx="10287000" cy="2857500"/>
           </a:xfrm>
           <a:prstGeom xmlns:a="http://schemas.openxmlformats.org/drawingml/2006/main" prst="rect">
             <a:avLst/>
@@ -1875,8 +1875,8 @@
         </p:nvSpPr>
         <p:spPr>
           <a:xfrm xmlns:a="http://schemas.openxmlformats.org/drawingml/2006/main">
-            <a:off x="1333500" y="15144750"/>
-            <a:ext cx="11049000" cy="666750"/>
+            <a:off x="1333500" y="14954250"/>
+            <a:ext cx="10287000" cy="666750"/>
           </a:xfrm>
           <a:prstGeom xmlns:a="http://schemas.openxmlformats.org/drawingml/2006/main" prst="rect">
             <a:avLst/>
@@ -1934,8 +1934,8 @@
         </p:nvSpPr>
         <p:spPr>
           <a:xfrm xmlns:a="http://schemas.openxmlformats.org/drawingml/2006/main">
-            <a:off x="1333500" y="15906750"/>
-            <a:ext cx="11049000" cy="3333750"/>
+            <a:off x="1333500" y="15668625"/>
+            <a:ext cx="10287000" cy="3048000"/>
           </a:xfrm>
           <a:prstGeom xmlns:a="http://schemas.openxmlformats.org/drawingml/2006/main" prst="rect">
             <a:avLst/>
@@ -1997,8 +1997,8 @@
         </p:nvSpPr>
         <p:spPr>
           <a:xfrm xmlns:a="http://schemas.openxmlformats.org/drawingml/2006/main">
-            <a:off x="1333500" y="19526250"/>
-            <a:ext cx="11049000" cy="666750"/>
+            <a:off x="1333500" y="18859500"/>
+            <a:ext cx="10287000" cy="666750"/>
           </a:xfrm>
           <a:prstGeom xmlns:a="http://schemas.openxmlformats.org/drawingml/2006/main" prst="rect">
             <a:avLst/>
@@ -2056,8 +2056,8 @@
         </p:nvSpPr>
         <p:spPr>
           <a:xfrm xmlns:a="http://schemas.openxmlformats.org/drawingml/2006/main">
-            <a:off x="1333500" y="20288250"/>
-            <a:ext cx="11049000" cy="2762250"/>
+            <a:off x="1333500" y="19621500"/>
+            <a:ext cx="10287000" cy="2762250"/>
           </a:xfrm>
           <a:prstGeom xmlns:a="http://schemas.openxmlformats.org/drawingml/2006/main" prst="rect">
             <a:avLst/>
@@ -2167,8 +2167,8 @@
         </p:nvSpPr>
         <p:spPr>
           <a:xfrm xmlns:a="http://schemas.openxmlformats.org/drawingml/2006/main">
-            <a:off x="1333500" y="23336250"/>
-            <a:ext cx="11049000" cy="666750"/>
+            <a:off x="1333500" y="22574250"/>
+            <a:ext cx="10287000" cy="666750"/>
           </a:xfrm>
           <a:prstGeom xmlns:a="http://schemas.openxmlformats.org/drawingml/2006/main" prst="rect">
             <a:avLst/>
@@ -2226,8 +2226,8 @@
         </p:nvSpPr>
         <p:spPr>
           <a:xfrm xmlns:a="http://schemas.openxmlformats.org/drawingml/2006/main">
-            <a:off x="1333500" y="24098250"/>
-            <a:ext cx="11049000" cy="2762250"/>
+            <a:off x="1333500" y="23336250"/>
+            <a:ext cx="10287000" cy="3619500"/>
           </a:xfrm>
           <a:prstGeom xmlns:a="http://schemas.openxmlformats.org/drawingml/2006/main" prst="rect">
             <a:avLst/>
@@ -2313,8 +2313,8 @@
         </p:nvSpPr>
         <p:spPr>
           <a:xfrm xmlns:a="http://schemas.openxmlformats.org/drawingml/2006/main">
-            <a:off x="13335000" y="9525000"/>
-            <a:ext cx="16134000" cy="809625"/>
+            <a:off x="12382500" y="9525000"/>
+            <a:ext cx="18097500" cy="809625"/>
           </a:xfrm>
           <a:prstGeom xmlns:a="http://schemas.openxmlformats.org/drawingml/2006/main" prst="rect">
             <a:avLst/>
@@ -2372,8 +2372,8 @@
         </p:nvSpPr>
         <p:spPr>
           <a:xfrm xmlns:a="http://schemas.openxmlformats.org/drawingml/2006/main">
-            <a:off x="13335000" y="10506075"/>
-            <a:ext cx="16134000" cy="47625"/>
+            <a:off x="12382500" y="10506075"/>
+            <a:ext cx="18097500" cy="47625"/>
           </a:xfrm>
           <a:prstGeom xmlns:a="http://schemas.openxmlformats.org/drawingml/2006/main" prst="rect">
             <a:avLst/>
@@ -2403,8 +2403,8 @@
         </p:nvSpPr>
         <p:spPr>
           <a:xfrm xmlns:a="http://schemas.openxmlformats.org/drawingml/2006/main">
-            <a:off x="13335000" y="11144250"/>
-            <a:ext cx="16134000" cy="4667250"/>
+            <a:off x="12382500" y="11144250"/>
+            <a:ext cx="18097500" cy="5476875"/>
           </a:xfrm>
           <a:prstGeom xmlns:a="http://schemas.openxmlformats.org/drawingml/2006/main" prst="rect">
             <a:avLst/>
@@ -2436,8 +2436,8 @@
         </p:nvSpPr>
         <p:spPr>
           <a:xfrm xmlns:a="http://schemas.openxmlformats.org/drawingml/2006/main">
-            <a:off x="13954125" y="12917805"/>
-            <a:ext cx="14895750" cy="904875"/>
+            <a:off x="13001625" y="13049250"/>
+            <a:ext cx="16859250" cy="904875"/>
           </a:xfrm>
           <a:prstGeom xmlns:a="http://schemas.openxmlformats.org/drawingml/2006/main" prst="rect">
             <a:avLst/>
@@ -2499,8 +2499,8 @@
         </p:nvSpPr>
         <p:spPr>
           <a:xfrm xmlns:a="http://schemas.openxmlformats.org/drawingml/2006/main">
-            <a:off x="14239875" y="14013180"/>
-            <a:ext cx="14324250" cy="1866900"/>
+            <a:off x="13287375" y="14097000"/>
+            <a:ext cx="16287750" cy="1866900"/>
           </a:xfrm>
           <a:prstGeom xmlns:a="http://schemas.openxmlformats.org/drawingml/2006/main" prst="rect">
             <a:avLst/>
@@ -2562,8 +2562,474 @@
         </p:nvSpPr>
         <p:spPr>
           <a:xfrm xmlns:a="http://schemas.openxmlformats.org/drawingml/2006/main">
-            <a:off x="13335000" y="16097250"/>
-            <a:ext cx="16134000" cy="1190625"/>
+            <a:off x="12382500" y="16764000"/>
+            <a:ext cx="18097500" cy="619125"/>
+          </a:xfrm>
+          <a:prstGeom xmlns:a="http://schemas.openxmlformats.org/drawingml/2006/main" prst="rect">
+            <a:avLst/>
+          </a:prstGeom>
+          <a:noFill xmlns:a="http://schemas.openxmlformats.org/drawingml/2006/main"/>
+          <a:ln xmlns:a="http://schemas.openxmlformats.org/drawingml/2006/main" w="0">
+            <a:noFill/>
+            <a:prstDash val="solid"/>
+          </a:ln>
+        </p:spPr>
+        <p:txBody>
+          <a:bodyPr xmlns:a="http://schemas.openxmlformats.org/drawingml/2006/main">
+            <a:noAutofit/>
+          </a:bodyPr>
+          <a:lstStyle xmlns:a="http://schemas.openxmlformats.org/drawingml/2006/main">
+            <a:defPPr>
+              <a:defRPr sz="2175"/>
+            </a:defPPr>
+          </a:lstStyle>
+          <a:p xmlns:a="http://schemas.openxmlformats.org/drawingml/2006/main">
+            <a:pPr algn="l">
+              <a:buNone/>
+              <a:defRPr sz="2175" b="0">
+                <a:solidFill>
+                  <a:srgbClr val="56616B"/>
+                </a:solidFill>
+                <a:latin typeface="Calibri"/>
+                <a:ea typeface="Calibri"/>
+                <a:cs typeface="Calibri"/>
+              </a:defRPr>
+            </a:pPr>
+            <a:r>
+              <a:rPr sz="2175" b="0">
+                <a:solidFill>
+                  <a:srgbClr val="56616B"/>
+                </a:solidFill>
+                <a:latin typeface="Calibri"/>
+                <a:ea typeface="Calibri"/>
+                <a:cs typeface="Calibri"/>
+              </a:rPr>
+              <a:t>Figure 1. Closest foundations lead to an endogenous-disclosure Bayesian model, verified BNE and welfare, proposed CCAR, computation, and explicit limitations.</a:t>
+            </a:r>
+          </a:p>
+        </p:txBody>
+      </p:sp>
+      <p:sp>
+        <p:nvSpPr>
+          <p:cNvPr id="27" name="main-result-area">
+            <a:extLst xmlns:a="http://schemas.openxmlformats.org/drawingml/2006/main">
+              <a:ext uri="{FF2B5EF4-FFF2-40B4-BE49-F238E27FC236}">
+                <a16:creationId xmlns:a16="http://schemas.microsoft.com/office/drawing/2014/main" id="{AF352E9D-B9F1-4E49-9DC0-059C3E7F7E02}"/>
+              </a:ext>
+            </a:extLst>
+          </p:cNvPr>
+          <p:cNvSpPr>
+            <a:spLocks xmlns:a="http://schemas.openxmlformats.org/drawingml/2006/main" noGrp="1"/>
+          </p:cNvSpPr>
+          <p:nvPr/>
+        </p:nvSpPr>
+        <p:spPr>
+          <a:xfrm xmlns:a="http://schemas.openxmlformats.org/drawingml/2006/main">
+            <a:off x="12382500" y="17621250"/>
+            <a:ext cx="12001500" cy="6762750"/>
+          </a:xfrm>
+          <a:prstGeom xmlns:a="http://schemas.openxmlformats.org/drawingml/2006/main" prst="rect">
+            <a:avLst/>
+          </a:prstGeom>
+          <a:solidFill xmlns:a="http://schemas.openxmlformats.org/drawingml/2006/main">
+            <a:srgbClr val="F4F6F7"/>
+          </a:solidFill>
+          <a:ln xmlns:a="http://schemas.openxmlformats.org/drawingml/2006/main" w="19050">
+            <a:solidFill>
+              <a:srgbClr val="CFD5D9"/>
+            </a:solidFill>
+            <a:prstDash val="solid"/>
+          </a:ln>
+        </p:spPr>
+      </p:sp>
+      <p:sp>
+        <p:nvSpPr>
+          <p:cNvPr id="28" name="main-result-label">
+            <a:extLst xmlns:a="http://schemas.openxmlformats.org/drawingml/2006/main">
+              <a:ext uri="{FF2B5EF4-FFF2-40B4-BE49-F238E27FC236}">
+                <a16:creationId xmlns:a16="http://schemas.microsoft.com/office/drawing/2014/main" id="{A95FDDB5-DC34-4CBB-B5F4-3B143142A5A8}"/>
+              </a:ext>
+            </a:extLst>
+          </p:cNvPr>
+          <p:cNvSpPr>
+            <a:spLocks xmlns:a="http://schemas.openxmlformats.org/drawingml/2006/main" noGrp="1"/>
+          </p:cNvSpPr>
+          <p:nvPr/>
+        </p:nvSpPr>
+        <p:spPr>
+          <a:xfrm xmlns:a="http://schemas.openxmlformats.org/drawingml/2006/main">
+            <a:off x="24669750" y="17621250"/>
+            <a:ext cx="5810250" cy="809625"/>
+          </a:xfrm>
+          <a:prstGeom xmlns:a="http://schemas.openxmlformats.org/drawingml/2006/main" prst="rect">
+            <a:avLst/>
+          </a:prstGeom>
+          <a:noFill xmlns:a="http://schemas.openxmlformats.org/drawingml/2006/main"/>
+          <a:ln xmlns:a="http://schemas.openxmlformats.org/drawingml/2006/main" w="0">
+            <a:noFill/>
+            <a:prstDash val="solid"/>
+          </a:ln>
+        </p:spPr>
+        <p:txBody>
+          <a:bodyPr xmlns:a="http://schemas.openxmlformats.org/drawingml/2006/main" anchor="ctr">
+            <a:noAutofit/>
+          </a:bodyPr>
+          <a:lstStyle xmlns:a="http://schemas.openxmlformats.org/drawingml/2006/main">
+            <a:defPPr algn="l">
+              <a:defRPr sz="3000"/>
+            </a:defPPr>
+          </a:lstStyle>
+          <a:p xmlns:a="http://schemas.openxmlformats.org/drawingml/2006/main">
+            <a:pPr algn="l">
+              <a:buNone/>
+              <a:defRPr sz="3000" b="1">
+                <a:solidFill>
+                  <a:srgbClr val="003399"/>
+                </a:solidFill>
+                <a:latin typeface="Calibri"/>
+                <a:ea typeface="Calibri"/>
+                <a:cs typeface="Calibri"/>
+              </a:defRPr>
+            </a:pPr>
+            <a:r>
+              <a:rPr sz="3000" b="1">
+                <a:solidFill>
+                  <a:srgbClr val="003399"/>
+                </a:solidFill>
+                <a:latin typeface="Calibri"/>
+                <a:ea typeface="Calibri"/>
+                <a:cs typeface="Calibri"/>
+              </a:rPr>
+              <a:t>Robustness and verification</a:t>
+            </a:r>
+          </a:p>
+        </p:txBody>
+      </p:sp>
+      <p:sp>
+        <p:nvSpPr>
+          <p:cNvPr id="29" name="main-result-prompt">
+            <a:extLst xmlns:a="http://schemas.openxmlformats.org/drawingml/2006/main">
+              <a:ext uri="{FF2B5EF4-FFF2-40B4-BE49-F238E27FC236}">
+                <a16:creationId xmlns:a16="http://schemas.microsoft.com/office/drawing/2014/main" id="{20FD9DFC-1B88-4B17-A251-EA9C62ACEF56}"/>
+              </a:ext>
+            </a:extLst>
+          </p:cNvPr>
+          <p:cNvSpPr>
+            <a:spLocks xmlns:a="http://schemas.openxmlformats.org/drawingml/2006/main" noGrp="1"/>
+          </p:cNvSpPr>
+          <p:nvPr/>
+        </p:nvSpPr>
+        <p:spPr>
+          <a:xfrm xmlns:a="http://schemas.openxmlformats.org/drawingml/2006/main">
+            <a:off x="24669750" y="18526125"/>
+            <a:ext cx="5810250" cy="8429625"/>
+          </a:xfrm>
+          <a:prstGeom xmlns:a="http://schemas.openxmlformats.org/drawingml/2006/main" prst="rect">
+            <a:avLst/>
+          </a:prstGeom>
+          <a:noFill xmlns:a="http://schemas.openxmlformats.org/drawingml/2006/main"/>
+          <a:ln xmlns:a="http://schemas.openxmlformats.org/drawingml/2006/main" w="0">
+            <a:noFill/>
+            <a:prstDash val="solid"/>
+          </a:ln>
+        </p:spPr>
+        <p:txBody>
+          <a:bodyPr xmlns:a="http://schemas.openxmlformats.org/drawingml/2006/main" anchor="t">
+            <a:noAutofit/>
+          </a:bodyPr>
+          <a:lstStyle xmlns:a="http://schemas.openxmlformats.org/drawingml/2006/main">
+            <a:defPPr algn="l">
+              <a:defRPr sz="2325">
+                <a:solidFill>
+                  <a:srgbClr val="212A33"/>
+                </a:solidFill>
+              </a:defRPr>
+            </a:defPPr>
+          </a:lstStyle>
+          <a:p xmlns:a="http://schemas.openxmlformats.org/drawingml/2006/main">
+            <a:pPr algn="l">
+              <a:buNone/>
+              <a:defRPr sz="2325" b="0">
+                <a:solidFill>
+                  <a:srgbClr val="212A33"/>
+                </a:solidFill>
+                <a:latin typeface="Calibri"/>
+                <a:ea typeface="Calibri"/>
+                <a:cs typeface="Calibri"/>
+              </a:defRPr>
+            </a:pPr>
+            <a:r>
+              <a:rPr sz="2325" b="0">
+                <a:solidFill>
+                  <a:srgbClr val="212A33"/>
+                </a:solidFill>
+                <a:latin typeface="Calibri"/>
+                <a:ea typeface="Calibri"/>
+                <a:cs typeface="Calibri"/>
+              </a:rPr>
+              <a:t>760 deterministic grid cells</a:t>
+            </a:r>
+          </a:p>
+          <a:p xmlns:a="http://schemas.openxmlformats.org/drawingml/2006/main">
+            <a:pPr algn="l">
+              <a:buNone/>
+              <a:defRPr sz="2325" b="0">
+                <a:solidFill>
+                  <a:srgbClr val="212A33"/>
+                </a:solidFill>
+                <a:latin typeface="Calibri"/>
+                <a:ea typeface="Calibri"/>
+                <a:cs typeface="Calibri"/>
+              </a:defRPr>
+            </a:pPr>
+            <a:r>
+              <a:rPr sz="2325" b="0">
+                <a:solidFill>
+                  <a:srgbClr val="212A33"/>
+                </a:solidFill>
+                <a:latin typeface="Calibri"/>
+                <a:ea typeface="Calibri"/>
+                <a:cs typeface="Calibri"/>
+              </a:rPr>
+              <a:t>401 no-effect</a:t>
+            </a:r>
+          </a:p>
+          <a:p xmlns:a="http://schemas.openxmlformats.org/drawingml/2006/main">
+            <a:pPr algn="l">
+              <a:buNone/>
+              <a:defRPr sz="2325" b="0">
+                <a:solidFill>
+                  <a:srgbClr val="212A33"/>
+                </a:solidFill>
+                <a:latin typeface="Calibri"/>
+                <a:ea typeface="Calibri"/>
+                <a:cs typeface="Calibri"/>
+              </a:defRPr>
+            </a:pPr>
+            <a:r>
+              <a:rPr sz="2325" b="0">
+                <a:solidFill>
+                  <a:srgbClr val="212A33"/>
+                </a:solidFill>
+                <a:latin typeface="Calibri"/>
+                <a:ea typeface="Calibri"/>
+                <a:cs typeface="Calibri"/>
+              </a:rPr>
+              <a:t>334 robust improvements</a:t>
+            </a:r>
+          </a:p>
+          <a:p xmlns:a="http://schemas.openxmlformats.org/drawingml/2006/main">
+            <a:pPr algn="l">
+              <a:buNone/>
+              <a:defRPr sz="2325" b="0">
+                <a:solidFill>
+                  <a:srgbClr val="212A33"/>
+                </a:solidFill>
+                <a:latin typeface="Calibri"/>
+                <a:ea typeface="Calibri"/>
+                <a:cs typeface="Calibri"/>
+              </a:defRPr>
+            </a:pPr>
+            <a:r>
+              <a:rPr sz="2325" b="0">
+                <a:solidFill>
+                  <a:srgbClr val="212A33"/>
+                </a:solidFill>
+                <a:latin typeface="Calibri"/>
+                <a:ea typeface="Calibri"/>
+                <a:cs typeface="Calibri"/>
+              </a:rPr>
+              <a:t>18 excessive-disclosure flags</a:t>
+            </a:r>
+          </a:p>
+          <a:p xmlns:a="http://schemas.openxmlformats.org/drawingml/2006/main">
+            <a:pPr algn="l">
+              <a:buNone/>
+              <a:defRPr sz="2325" b="0">
+                <a:solidFill>
+                  <a:srgbClr val="212A33"/>
+                </a:solidFill>
+                <a:latin typeface="Calibri"/>
+                <a:ea typeface="Calibri"/>
+                <a:cs typeface="Calibri"/>
+              </a:defRPr>
+            </a:pPr>
+            <a:r>
+              <a:rPr sz="2325" b="0">
+                <a:solidFill>
+                  <a:srgbClr val="212A33"/>
+                </a:solidFill>
+                <a:latin typeface="Calibri"/>
+                <a:ea typeface="Calibri"/>
+                <a:cs typeface="Calibri"/>
+              </a:rPr>
+              <a:t>3 larger-gap</a:t>
+            </a:r>
+          </a:p>
+          <a:p xmlns:a="http://schemas.openxmlformats.org/drawingml/2006/main">
+            <a:pPr algn="l">
+              <a:buNone/>
+              <a:defRPr sz="2325" b="0">
+                <a:solidFill>
+                  <a:srgbClr val="212A33"/>
+                </a:solidFill>
+                <a:latin typeface="Calibri"/>
+                <a:ea typeface="Calibri"/>
+                <a:cs typeface="Calibri"/>
+              </a:defRPr>
+            </a:pPr>
+            <a:r>
+              <a:rPr sz="2325" b="0">
+                <a:solidFill>
+                  <a:srgbClr val="212A33"/>
+                </a:solidFill>
+                <a:latin typeface="Calibri"/>
+                <a:ea typeface="Calibri"/>
+                <a:cs typeface="Calibri"/>
+              </a:rPr>
+              <a:t>66 multiple CCAR BNE</a:t>
+            </a:r>
+          </a:p>
+          <a:p xmlns:a="http://schemas.openxmlformats.org/drawingml/2006/main">
+            <a:pPr algn="l">
+              <a:buNone/>
+              <a:defRPr sz="2325" b="0">
+                <a:solidFill>
+                  <a:srgbClr val="212A33"/>
+                </a:solidFill>
+                <a:latin typeface="Calibri"/>
+                <a:ea typeface="Calibri"/>
+                <a:cs typeface="Calibri"/>
+              </a:defRPr>
+            </a:pPr>
+            <a:r>
+              <a:rPr sz="2325" b="0">
+                <a:solidFill>
+                  <a:srgbClr val="212A33"/>
+                </a:solidFill>
+                <a:latin typeface="Calibri"/>
+                <a:ea typeface="Calibri"/>
+                <a:cs typeface="Calibri"/>
+              </a:rPr>
+              <a:t>Diagnostics overlap.</a:t>
+            </a:r>
+          </a:p>
+          <a:p xmlns:a="http://schemas.openxmlformats.org/drawingml/2006/main">
+            <a:pPr algn="ctr">
+              <a:buNone/>
+              <a:defRPr sz="2925" b="0">
+                <a:solidFill>
+                  <a:srgbClr val="56616B"/>
+                </a:solidFill>
+                <a:latin typeface="Calibri"/>
+                <a:ea typeface="Calibri"/>
+                <a:cs typeface="Calibri"/>
+              </a:defRPr>
+            </a:pPr>
+            <a:r>
+              <a:rPr sz="2925" b="0">
+                <a:solidFill>
+                  <a:srgbClr val="56616B"/>
+                </a:solidFill>
+                <a:latin typeface="Calibri"/>
+                <a:ea typeface="Calibri"/>
+                <a:cs typeface="Calibri"/>
+              </a:rPr>
+              <a:t/>
+            </a:r>
+          </a:p>
+          <a:p xmlns:a="http://schemas.openxmlformats.org/drawingml/2006/main">
+            <a:pPr algn="l">
+              <a:buNone/>
+              <a:defRPr sz="2325" b="0">
+                <a:solidFill>
+                  <a:srgbClr val="212A33"/>
+                </a:solidFill>
+                <a:latin typeface="Calibri"/>
+                <a:ea typeface="Calibri"/>
+                <a:cs typeface="Calibri"/>
+              </a:defRPr>
+            </a:pPr>
+            <a:r>
+              <a:rPr sz="2325" b="0">
+                <a:solidFill>
+                  <a:srgbClr val="212A33"/>
+                </a:solidFill>
+                <a:latin typeface="Calibri"/>
+                <a:ea typeface="Calibri"/>
+                <a:cs typeface="Calibri"/>
+              </a:rPr>
+              <a:t>Exhaustive 81-profile search</a:t>
+            </a:r>
+          </a:p>
+          <a:p xmlns:a="http://schemas.openxmlformats.org/drawingml/2006/main">
+            <a:pPr algn="l">
+              <a:buNone/>
+              <a:defRPr sz="2325" b="0">
+                <a:solidFill>
+                  <a:srgbClr val="212A33"/>
+                </a:solidFill>
+                <a:latin typeface="Calibri"/>
+                <a:ea typeface="Calibri"/>
+                <a:cs typeface="Calibri"/>
+              </a:defRPr>
+            </a:pPr>
+            <a:r>
+              <a:rPr sz="2325" b="0">
+                <a:solidFill>
+                  <a:srgbClr val="212A33"/>
+                </a:solidFill>
+                <a:latin typeface="Calibri"/>
+                <a:ea typeface="Calibri"/>
+                <a:cs typeface="Calibri"/>
+              </a:rPr>
+              <a:t>Evidence: stylized computation</a:t>
+            </a:r>
+          </a:p>
+          <a:p xmlns:a="http://schemas.openxmlformats.org/drawingml/2006/main">
+            <a:pPr algn="l">
+              <a:buNone/>
+              <a:defRPr sz="2325" b="0">
+                <a:solidFill>
+                  <a:srgbClr val="212A33"/>
+                </a:solidFill>
+                <a:latin typeface="Calibri"/>
+                <a:ea typeface="Calibri"/>
+                <a:cs typeface="Calibri"/>
+              </a:defRPr>
+            </a:pPr>
+            <a:r>
+              <a:rPr sz="2325" b="0">
+                <a:solidFill>
+                  <a:srgbClr val="212A33"/>
+                </a:solidFill>
+                <a:latin typeface="Calibri"/>
+                <a:ea typeface="Calibri"/>
+                <a:cs typeface="Calibri"/>
+              </a:rPr>
+              <a:t>Source: outputs/final/</a:t>
+            </a:r>
+          </a:p>
+        </p:txBody>
+      </p:sp>
+      <p:sp>
+        <p:nvSpPr>
+          <p:cNvPr id="30" name="result-caption">
+            <a:extLst xmlns:a="http://schemas.openxmlformats.org/drawingml/2006/main">
+              <a:ext uri="{FF2B5EF4-FFF2-40B4-BE49-F238E27FC236}">
+                <a16:creationId xmlns:a16="http://schemas.microsoft.com/office/drawing/2014/main" id="{C7A388AE-9A9C-4C69-A215-69F12E632900}"/>
+              </a:ext>
+            </a:extLst>
+          </p:cNvPr>
+          <p:cNvSpPr>
+            <a:spLocks xmlns:a="http://schemas.openxmlformats.org/drawingml/2006/main" noGrp="1"/>
+          </p:cNvSpPr>
+          <p:nvPr/>
+        </p:nvSpPr>
+        <p:spPr>
+          <a:xfrm xmlns:a="http://schemas.openxmlformats.org/drawingml/2006/main">
+            <a:off x="12382500" y="24574500"/>
+            <a:ext cx="12001500" cy="2381250"/>
           </a:xfrm>
           <a:prstGeom xmlns:a="http://schemas.openxmlformats.org/drawingml/2006/main" prst="rect">
             <a:avLst/>
@@ -2588,7 +3054,7 @@
               <a:buNone/>
               <a:defRPr sz="2325" b="0">
                 <a:solidFill>
-                  <a:srgbClr val="56616B"/>
+                  <a:srgbClr val="212A33"/>
                 </a:solidFill>
                 <a:latin typeface="Calibri"/>
                 <a:ea typeface="Calibri"/>
@@ -2598,68 +3064,280 @@
             <a:r>
               <a:rPr sz="2325" b="0">
                 <a:solidFill>
-                  <a:srgbClr val="56616B"/>
-                </a:solidFill>
-                <a:latin typeface="Calibri"/>
-                <a:ea typeface="Calibri"/>
-                <a:cs typeface="Calibri"/>
-              </a:rPr>
-              <a:t>Figure 1. Three closest foundations feed an endogenous-disclosure Bayesian model, welfare benchmark, CCAR test, and explicit limitations.</a:t>
+                  <a:srgbClr val="212A33"/>
+                </a:solidFill>
+                <a:latin typeface="Calibri"/>
+                <a:ea typeface="Calibri"/>
+                <a:cs typeface="Calibri"/>
+              </a:rPr>
+              <a:t>Figure 2. Expected normalized welfare</a:t>
+            </a:r>
+          </a:p>
+          <a:p xmlns:a="http://schemas.openxmlformats.org/drawingml/2006/main">
+            <a:pPr algn="l">
+              <a:buNone/>
+              <a:defRPr sz="2325" b="0">
+                <a:solidFill>
+                  <a:srgbClr val="212A33"/>
+                </a:solidFill>
+                <a:latin typeface="Calibri"/>
+                <a:ea typeface="Calibri"/>
+                <a:cs typeface="Calibri"/>
+              </a:defRPr>
+            </a:pPr>
+            <a:r>
+              <a:rPr sz="2325" b="0">
+                <a:solidFill>
+                  <a:srgbClr val="212A33"/>
+                </a:solidFill>
+                <a:latin typeface="Calibri"/>
+                <a:ea typeface="Calibri"/>
+                <a:cs typeface="Calibri"/>
+              </a:rPr>
+              <a:t>Low: 0.000 / 0.639</a:t>
+            </a:r>
+          </a:p>
+          <a:p xmlns:a="http://schemas.openxmlformats.org/drawingml/2006/main">
+            <a:pPr algn="l">
+              <a:buNone/>
+              <a:defRPr sz="2325" b="0">
+                <a:solidFill>
+                  <a:srgbClr val="212A33"/>
+                </a:solidFill>
+                <a:latin typeface="Calibri"/>
+                <a:ea typeface="Calibri"/>
+                <a:cs typeface="Calibri"/>
+              </a:defRPr>
+            </a:pPr>
+            <a:r>
+              <a:rPr sz="2325" b="0">
+                <a:solidFill>
+                  <a:srgbClr val="212A33"/>
+                </a:solidFill>
+                <a:latin typeface="Calibri"/>
+                <a:ea typeface="Calibri"/>
+                <a:cs typeface="Calibri"/>
+              </a:rPr>
+              <a:t>Medium: 2.193 / 3.089 / 3.139</a:t>
+            </a:r>
+          </a:p>
+          <a:p xmlns:a="http://schemas.openxmlformats.org/drawingml/2006/main">
+            <a:pPr algn="l">
+              <a:buNone/>
+              <a:defRPr sz="2325" b="0">
+                <a:solidFill>
+                  <a:srgbClr val="212A33"/>
+                </a:solidFill>
+                <a:latin typeface="Calibri"/>
+                <a:ea typeface="Calibri"/>
+                <a:cs typeface="Calibri"/>
+              </a:defRPr>
+            </a:pPr>
+            <a:r>
+              <a:rPr sz="2325" b="0">
+                <a:solidFill>
+                  <a:srgbClr val="212A33"/>
+                </a:solidFill>
+                <a:latin typeface="Calibri"/>
+                <a:ea typeface="Calibri"/>
+                <a:cs typeface="Calibri"/>
+              </a:rPr>
+              <a:t>High: 6.882 / 6.882 / 7.385</a:t>
+            </a:r>
+          </a:p>
+          <a:p xmlns:a="http://schemas.openxmlformats.org/drawingml/2006/main">
+            <a:pPr algn="l">
+              <a:buNone/>
+              <a:defRPr sz="2325" b="0">
+                <a:solidFill>
+                  <a:srgbClr val="212A33"/>
+                </a:solidFill>
+                <a:latin typeface="Calibri"/>
+                <a:ea typeface="Calibri"/>
+                <a:cs typeface="Calibri"/>
+              </a:defRPr>
+            </a:pPr>
+            <a:r>
+              <a:rPr sz="2325" b="0">
+                <a:solidFill>
+                  <a:srgbClr val="212A33"/>
+                </a:solidFill>
+                <a:latin typeface="Calibri"/>
+                <a:ea typeface="Calibri"/>
+                <a:cs typeface="Calibri"/>
+              </a:rPr>
+              <a:t>(BNE / CCAR / first best).</a:t>
             </a:r>
           </a:p>
         </p:txBody>
       </p:sp>
       <p:sp>
         <p:nvSpPr>
-          <p:cNvPr id="27" name="main-result-area">
-            <a:extLst xmlns:a="http://schemas.openxmlformats.org/drawingml/2006/main">
-              <a:ext uri="{FF2B5EF4-FFF2-40B4-BE49-F238E27FC236}">
-                <a16:creationId xmlns:a16="http://schemas.microsoft.com/office/drawing/2014/main" id="{AF352E9D-B9F1-4E49-9DC0-059C3E7F7E02}"/>
-              </a:ext>
-            </a:extLst>
-          </p:cNvPr>
-          <p:cNvSpPr>
-            <a:spLocks xmlns:a="http://schemas.openxmlformats.org/drawingml/2006/main" noGrp="1"/>
-          </p:cNvSpPr>
-          <p:nvPr/>
-        </p:nvSpPr>
-        <p:spPr>
-          <a:xfrm xmlns:a="http://schemas.openxmlformats.org/drawingml/2006/main">
-            <a:off x="13335000" y="17621250"/>
-            <a:ext cx="16134000" cy="6286500"/>
+          <p:cNvPr id="31" name="impact-title">
+            <a:extLst xmlns:a="http://schemas.openxmlformats.org/drawingml/2006/main">
+              <a:ext uri="{FF2B5EF4-FFF2-40B4-BE49-F238E27FC236}">
+                <a16:creationId xmlns:a16="http://schemas.microsoft.com/office/drawing/2014/main" id="{7974BDE9-47C8-4976-9EB0-1D99D2AD436D}"/>
+              </a:ext>
+            </a:extLst>
+          </p:cNvPr>
+          <p:cNvSpPr>
+            <a:spLocks xmlns:a="http://schemas.openxmlformats.org/drawingml/2006/main" noGrp="1"/>
+          </p:cNvSpPr>
+          <p:nvPr/>
+        </p:nvSpPr>
+        <p:spPr>
+          <a:xfrm xmlns:a="http://schemas.openxmlformats.org/drawingml/2006/main">
+            <a:off x="31242000" y="9525000"/>
+            <a:ext cx="10229850" cy="809625"/>
+          </a:xfrm>
+          <a:prstGeom xmlns:a="http://schemas.openxmlformats.org/drawingml/2006/main" prst="rect">
+            <a:avLst/>
+          </a:prstGeom>
+          <a:noFill xmlns:a="http://schemas.openxmlformats.org/drawingml/2006/main"/>
+          <a:ln xmlns:a="http://schemas.openxmlformats.org/drawingml/2006/main" w="0">
+            <a:noFill/>
+            <a:prstDash val="solid"/>
+          </a:ln>
+        </p:spPr>
+        <p:txBody>
+          <a:bodyPr xmlns:a="http://schemas.openxmlformats.org/drawingml/2006/main">
+            <a:noAutofit/>
+          </a:bodyPr>
+          <a:lstStyle xmlns:a="http://schemas.openxmlformats.org/drawingml/2006/main"/>
+          <a:p xmlns:a="http://schemas.openxmlformats.org/drawingml/2006/main">
+            <a:pPr algn="l">
+              <a:buNone/>
+              <a:defRPr sz="4650" b="1">
+                <a:solidFill>
+                  <a:srgbClr val="003399"/>
+                </a:solidFill>
+                <a:latin typeface="Calibri"/>
+                <a:ea typeface="Calibri"/>
+                <a:cs typeface="Calibri"/>
+              </a:defRPr>
+            </a:pPr>
+            <a:r>
+              <a:rPr sz="4650" b="1">
+                <a:solidFill>
+                  <a:srgbClr val="003399"/>
+                </a:solidFill>
+                <a:latin typeface="Calibri"/>
+                <a:ea typeface="Calibri"/>
+                <a:cs typeface="Calibri"/>
+              </a:rPr>
+              <a:t>03   Practical impacts and roadmap</a:t>
+            </a:r>
+          </a:p>
+        </p:txBody>
+      </p:sp>
+      <p:sp>
+        <p:nvSpPr>
+          <p:cNvPr id="32" name="impact-title-rule">
+            <a:extLst xmlns:a="http://schemas.openxmlformats.org/drawingml/2006/main">
+              <a:ext uri="{FF2B5EF4-FFF2-40B4-BE49-F238E27FC236}">
+                <a16:creationId xmlns:a16="http://schemas.microsoft.com/office/drawing/2014/main" id="{92EF0681-32CB-4E92-B477-91FDD7DB084E}"/>
+              </a:ext>
+            </a:extLst>
+          </p:cNvPr>
+          <p:cNvSpPr>
+            <a:spLocks xmlns:a="http://schemas.openxmlformats.org/drawingml/2006/main" noGrp="1"/>
+          </p:cNvSpPr>
+          <p:nvPr/>
+        </p:nvSpPr>
+        <p:spPr>
+          <a:xfrm xmlns:a="http://schemas.openxmlformats.org/drawingml/2006/main">
+            <a:off x="31242000" y="10506075"/>
+            <a:ext cx="10229850" cy="47625"/>
           </a:xfrm>
           <a:prstGeom xmlns:a="http://schemas.openxmlformats.org/drawingml/2006/main" prst="rect">
             <a:avLst/>
           </a:prstGeom>
           <a:solidFill xmlns:a="http://schemas.openxmlformats.org/drawingml/2006/main">
-            <a:srgbClr val="F4F6F7"/>
+            <a:srgbClr val="006633"/>
           </a:solidFill>
-          <a:ln xmlns:a="http://schemas.openxmlformats.org/drawingml/2006/main" w="19050">
-            <a:solidFill>
-              <a:srgbClr val="CFD5D9"/>
-            </a:solidFill>
-            <a:prstDash val="solid"/>
-          </a:ln>
-        </p:spPr>
-      </p:sp>
-      <p:sp>
-        <p:nvSpPr>
-          <p:cNvPr id="28" name="main-result-label">
-            <a:extLst xmlns:a="http://schemas.openxmlformats.org/drawingml/2006/main">
-              <a:ext uri="{FF2B5EF4-FFF2-40B4-BE49-F238E27FC236}">
-                <a16:creationId xmlns:a16="http://schemas.microsoft.com/office/drawing/2014/main" id="{A95FDDB5-DC34-4CBB-B5F4-3B143142A5A8}"/>
-              </a:ext>
-            </a:extLst>
-          </p:cNvPr>
-          <p:cNvSpPr>
-            <a:spLocks xmlns:a="http://schemas.openxmlformats.org/drawingml/2006/main" noGrp="1"/>
-          </p:cNvSpPr>
-          <p:nvPr/>
-        </p:nvSpPr>
-        <p:spPr>
-          <a:xfrm xmlns:a="http://schemas.openxmlformats.org/drawingml/2006/main">
-            <a:off x="13954125" y="20010120"/>
-            <a:ext cx="14895750" cy="904875"/>
+          <a:ln xmlns:a="http://schemas.openxmlformats.org/drawingml/2006/main" w="0">
+            <a:noFill/>
+            <a:prstDash val="solid"/>
+          </a:ln>
+        </p:spPr>
+      </p:sp>
+      <p:sp>
+        <p:nvSpPr>
+          <p:cNvPr id="33" name="real-world-heading">
+            <a:extLst xmlns:a="http://schemas.openxmlformats.org/drawingml/2006/main">
+              <a:ext uri="{FF2B5EF4-FFF2-40B4-BE49-F238E27FC236}">
+                <a16:creationId xmlns:a16="http://schemas.microsoft.com/office/drawing/2014/main" id="{8D7A544D-17E0-43AC-A769-0DC992E2E072}"/>
+              </a:ext>
+            </a:extLst>
+          </p:cNvPr>
+          <p:cNvSpPr>
+            <a:spLocks xmlns:a="http://schemas.openxmlformats.org/drawingml/2006/main" noGrp="1"/>
+          </p:cNvSpPr>
+          <p:nvPr/>
+        </p:nvSpPr>
+        <p:spPr>
+          <a:xfrm xmlns:a="http://schemas.openxmlformats.org/drawingml/2006/main">
+            <a:off x="31242000" y="11144250"/>
+            <a:ext cx="10229850" cy="666750"/>
+          </a:xfrm>
+          <a:prstGeom xmlns:a="http://schemas.openxmlformats.org/drawingml/2006/main" prst="rect">
+            <a:avLst/>
+          </a:prstGeom>
+          <a:noFill xmlns:a="http://schemas.openxmlformats.org/drawingml/2006/main"/>
+          <a:ln xmlns:a="http://schemas.openxmlformats.org/drawingml/2006/main" w="0">
+            <a:noFill/>
+            <a:prstDash val="solid"/>
+          </a:ln>
+        </p:spPr>
+        <p:txBody>
+          <a:bodyPr xmlns:a="http://schemas.openxmlformats.org/drawingml/2006/main">
+            <a:noAutofit/>
+          </a:bodyPr>
+          <a:lstStyle xmlns:a="http://schemas.openxmlformats.org/drawingml/2006/main"/>
+          <a:p xmlns:a="http://schemas.openxmlformats.org/drawingml/2006/main">
+            <a:pPr algn="l">
+              <a:buNone/>
+              <a:defRPr sz="3375" b="1">
+                <a:solidFill>
+                  <a:srgbClr val="003399"/>
+                </a:solidFill>
+                <a:latin typeface="Calibri"/>
+                <a:ea typeface="Calibri"/>
+                <a:cs typeface="Calibri"/>
+              </a:defRPr>
+            </a:pPr>
+            <a:r>
+              <a:rPr sz="3375" b="1">
+                <a:solidFill>
+                  <a:srgbClr val="003399"/>
+                </a:solidFill>
+                <a:latin typeface="Calibri"/>
+                <a:ea typeface="Calibri"/>
+                <a:cs typeface="Calibri"/>
+              </a:rPr>
+              <a:t>Practical Impacts diagram with SDG targets</a:t>
+            </a:r>
+          </a:p>
+        </p:txBody>
+      </p:sp>
+      <p:sp>
+        <p:nvSpPr>
+          <p:cNvPr id="34" name="real-world">
+            <a:extLst xmlns:a="http://schemas.openxmlformats.org/drawingml/2006/main">
+              <a:ext uri="{FF2B5EF4-FFF2-40B4-BE49-F238E27FC236}">
+                <a16:creationId xmlns:a16="http://schemas.microsoft.com/office/drawing/2014/main" id="{2199F087-3016-48E4-80F0-4F875A71FCDD}"/>
+              </a:ext>
+            </a:extLst>
+          </p:cNvPr>
+          <p:cNvSpPr>
+            <a:spLocks xmlns:a="http://schemas.openxmlformats.org/drawingml/2006/main" noGrp="1"/>
+          </p:cNvSpPr>
+          <p:nvPr/>
+        </p:nvSpPr>
+        <p:spPr>
+          <a:xfrm xmlns:a="http://schemas.openxmlformats.org/drawingml/2006/main">
+            <a:off x="31242000" y="11858625"/>
+            <a:ext cx="10229850" cy="4286250"/>
           </a:xfrm>
           <a:prstGeom xmlns:a="http://schemas.openxmlformats.org/drawingml/2006/main" prst="rect">
             <a:avLst/>
@@ -2680,9 +3358,68 @@
             </a:defPPr>
           </a:lstStyle>
           <a:p xmlns:a="http://schemas.openxmlformats.org/drawingml/2006/main">
-            <a:pPr algn="ctr">
-              <a:buNone/>
-              <a:defRPr sz="3600" b="1">
+            <a:pPr algn="l">
+              <a:buNone/>
+              <a:defRPr sz="3300" b="0">
+                <a:solidFill>
+                  <a:srgbClr val="212A33"/>
+                </a:solidFill>
+                <a:latin typeface="Calibri"/>
+                <a:ea typeface="Calibri"/>
+                <a:cs typeface="Calibri"/>
+              </a:defRPr>
+            </a:pPr>
+            <a:r>
+              <a:rPr sz="3300" b="0">
+                <a:solidFill>
+                  <a:srgbClr val="212A33"/>
+                </a:solidFill>
+                <a:latin typeface="Calibri"/>
+                <a:ea typeface="Calibri"/>
+                <a:cs typeface="Calibri"/>
+              </a:rPr>
+              <a:t/>
+            </a:r>
+          </a:p>
+        </p:txBody>
+      </p:sp>
+      <p:sp>
+        <p:nvSpPr>
+          <p:cNvPr id="35" name="interdisciplinary-heading">
+            <a:extLst xmlns:a="http://schemas.openxmlformats.org/drawingml/2006/main">
+              <a:ext uri="{FF2B5EF4-FFF2-40B4-BE49-F238E27FC236}">
+                <a16:creationId xmlns:a16="http://schemas.microsoft.com/office/drawing/2014/main" id="{1E996ED0-A32A-4617-8E65-E6ED026E62D8}"/>
+              </a:ext>
+            </a:extLst>
+          </p:cNvPr>
+          <p:cNvSpPr>
+            <a:spLocks xmlns:a="http://schemas.openxmlformats.org/drawingml/2006/main" noGrp="1"/>
+          </p:cNvSpPr>
+          <p:nvPr/>
+        </p:nvSpPr>
+        <p:spPr>
+          <a:xfrm xmlns:a="http://schemas.openxmlformats.org/drawingml/2006/main">
+            <a:off x="31242000" y="16335375"/>
+            <a:ext cx="10229850" cy="666750"/>
+          </a:xfrm>
+          <a:prstGeom xmlns:a="http://schemas.openxmlformats.org/drawingml/2006/main" prst="rect">
+            <a:avLst/>
+          </a:prstGeom>
+          <a:noFill xmlns:a="http://schemas.openxmlformats.org/drawingml/2006/main"/>
+          <a:ln xmlns:a="http://schemas.openxmlformats.org/drawingml/2006/main" w="0">
+            <a:noFill/>
+            <a:prstDash val="solid"/>
+          </a:ln>
+        </p:spPr>
+        <p:txBody>
+          <a:bodyPr xmlns:a="http://schemas.openxmlformats.org/drawingml/2006/main">
+            <a:noAutofit/>
+          </a:bodyPr>
+          <a:lstStyle xmlns:a="http://schemas.openxmlformats.org/drawingml/2006/main"/>
+          <a:p xmlns:a="http://schemas.openxmlformats.org/drawingml/2006/main">
+            <a:pPr algn="l">
+              <a:buNone/>
+              <a:defRPr sz="3375" b="1">
                 <a:solidFill>
                   <a:srgbClr val="003399"/>
                 </a:solidFill>
@@ -2692,7 +3429,7 @@
               </a:defRPr>
             </a:pPr>
             <a:r>
-              <a:rPr sz="3600" b="1">
+              <a:rPr sz="3375" b="1">
                 <a:solidFill>
                   <a:srgbClr val="003399"/>
                 </a:solidFill>
@@ -2700,29 +3437,29 @@
                 <a:ea typeface="Calibri"/>
                 <a:cs typeface="Calibri"/>
               </a:rPr>
-              <a:t/>
+              <a:t>Future Research Roadmap new diagram</a:t>
             </a:r>
           </a:p>
         </p:txBody>
       </p:sp>
       <p:sp>
         <p:nvSpPr>
-          <p:cNvPr id="29" name="main-result-prompt">
-            <a:extLst xmlns:a="http://schemas.openxmlformats.org/drawingml/2006/main">
-              <a:ext uri="{FF2B5EF4-FFF2-40B4-BE49-F238E27FC236}">
-                <a16:creationId xmlns:a16="http://schemas.microsoft.com/office/drawing/2014/main" id="{20FD9DFC-1B88-4B17-A251-EA9C62ACEF56}"/>
-              </a:ext>
-            </a:extLst>
-          </p:cNvPr>
-          <p:cNvSpPr>
-            <a:spLocks xmlns:a="http://schemas.openxmlformats.org/drawingml/2006/main" noGrp="1"/>
-          </p:cNvSpPr>
-          <p:nvPr/>
-        </p:nvSpPr>
-        <p:spPr>
-          <a:xfrm xmlns:a="http://schemas.openxmlformats.org/drawingml/2006/main">
-            <a:off x="14239875" y="21105495"/>
-            <a:ext cx="14324250" cy="2514600"/>
+          <p:cNvPr id="36" name="interdisciplinary">
+            <a:extLst xmlns:a="http://schemas.openxmlformats.org/drawingml/2006/main">
+              <a:ext uri="{FF2B5EF4-FFF2-40B4-BE49-F238E27FC236}">
+                <a16:creationId xmlns:a16="http://schemas.microsoft.com/office/drawing/2014/main" id="{91D1D813-AECB-4965-9667-285D2DDCB3E4}"/>
+              </a:ext>
+            </a:extLst>
+          </p:cNvPr>
+          <p:cNvSpPr>
+            <a:spLocks xmlns:a="http://schemas.openxmlformats.org/drawingml/2006/main" noGrp="1"/>
+          </p:cNvSpPr>
+          <p:nvPr/>
+        </p:nvSpPr>
+        <p:spPr>
+          <a:xfrm xmlns:a="http://schemas.openxmlformats.org/drawingml/2006/main">
+            <a:off x="31242000" y="17097375"/>
+            <a:ext cx="10229850" cy="4953000"/>
           </a:xfrm>
           <a:prstGeom xmlns:a="http://schemas.openxmlformats.org/drawingml/2006/main" prst="rect">
             <a:avLst/>
@@ -2743,21 +3480,21 @@
             </a:defPPr>
           </a:lstStyle>
           <a:p xmlns:a="http://schemas.openxmlformats.org/drawingml/2006/main">
-            <a:pPr algn="ctr">
-              <a:buNone/>
-              <a:defRPr sz="2925" b="0">
-                <a:solidFill>
-                  <a:srgbClr val="56616B"/>
-                </a:solidFill>
-                <a:latin typeface="Calibri"/>
-                <a:ea typeface="Calibri"/>
-                <a:cs typeface="Calibri"/>
-              </a:defRPr>
-            </a:pPr>
-            <a:r>
-              <a:rPr sz="2925" b="0">
-                <a:solidFill>
-                  <a:srgbClr val="56616B"/>
+            <a:pPr algn="l">
+              <a:buNone/>
+              <a:defRPr sz="3225" b="0">
+                <a:solidFill>
+                  <a:srgbClr val="212A33"/>
+                </a:solidFill>
+                <a:latin typeface="Calibri"/>
+                <a:ea typeface="Calibri"/>
+                <a:cs typeface="Calibri"/>
+              </a:defRPr>
+            </a:pPr>
+            <a:r>
+              <a:rPr sz="3225" b="0">
+                <a:solidFill>
+                  <a:srgbClr val="212A33"/>
                 </a:solidFill>
                 <a:latin typeface="Calibri"/>
                 <a:ea typeface="Calibri"/>
@@ -2770,133 +3507,22 @@
       </p:sp>
       <p:sp>
         <p:nvSpPr>
-          <p:cNvPr id="30" name="result-caption">
-            <a:extLst xmlns:a="http://schemas.openxmlformats.org/drawingml/2006/main">
-              <a:ext uri="{FF2B5EF4-FFF2-40B4-BE49-F238E27FC236}">
-                <a16:creationId xmlns:a16="http://schemas.microsoft.com/office/drawing/2014/main" id="{C7A388AE-9A9C-4C69-A215-69F12E632900}"/>
-              </a:ext>
-            </a:extLst>
-          </p:cNvPr>
-          <p:cNvSpPr>
-            <a:spLocks xmlns:a="http://schemas.openxmlformats.org/drawingml/2006/main" noGrp="1"/>
-          </p:cNvSpPr>
-          <p:nvPr/>
-        </p:nvSpPr>
-        <p:spPr>
-          <a:xfrm xmlns:a="http://schemas.openxmlformats.org/drawingml/2006/main">
-            <a:off x="13335000" y="24241125"/>
-            <a:ext cx="16134000" cy="2714625"/>
-          </a:xfrm>
-          <a:prstGeom xmlns:a="http://schemas.openxmlformats.org/drawingml/2006/main" prst="rect">
-            <a:avLst/>
-          </a:prstGeom>
-          <a:noFill xmlns:a="http://schemas.openxmlformats.org/drawingml/2006/main"/>
-          <a:ln xmlns:a="http://schemas.openxmlformats.org/drawingml/2006/main" w="0">
-            <a:noFill/>
-            <a:prstDash val="solid"/>
-          </a:ln>
-        </p:spPr>
-        <p:txBody>
-          <a:bodyPr xmlns:a="http://schemas.openxmlformats.org/drawingml/2006/main">
-            <a:noAutofit/>
-          </a:bodyPr>
-          <a:lstStyle xmlns:a="http://schemas.openxmlformats.org/drawingml/2006/main">
-            <a:defPPr>
-              <a:defRPr sz="2400"/>
-            </a:defPPr>
-          </a:lstStyle>
-          <a:p xmlns:a="http://schemas.openxmlformats.org/drawingml/2006/main">
-            <a:pPr algn="l">
-              <a:buNone/>
-              <a:defRPr sz="2400" b="0">
-                <a:solidFill>
-                  <a:srgbClr val="212A33"/>
-                </a:solidFill>
-                <a:latin typeface="Calibri"/>
-                <a:ea typeface="Calibri"/>
-                <a:cs typeface="Calibri"/>
-              </a:defRPr>
-            </a:pPr>
-            <a:r>
-              <a:rPr sz="2400" b="0">
-                <a:solidFill>
-                  <a:srgbClr val="212A33"/>
-                </a:solidFill>
-                <a:latin typeface="Calibri"/>
-                <a:ea typeface="Calibri"/>
-                <a:cs typeface="Calibri"/>
-              </a:rPr>
-              <a:t>Figure 2. Expected normalized welfare. Low: 0.000 / 0.639. Medium: 2.193 / 3.089 / 3.139. High: 6.882 / 6.882 / 7.385 (BNE / CCAR / first best).</a:t>
-            </a:r>
-          </a:p>
-          <a:p xmlns:a="http://schemas.openxmlformats.org/drawingml/2006/main">
-            <a:pPr algn="l">
-              <a:buNone/>
-              <a:defRPr sz="2400" b="0">
-                <a:solidFill>
-                  <a:srgbClr val="212A33"/>
-                </a:solidFill>
-                <a:latin typeface="Calibri"/>
-                <a:ea typeface="Calibri"/>
-                <a:cs typeface="Calibri"/>
-              </a:defRPr>
-            </a:pPr>
-            <a:r>
-              <a:rPr sz="2400" b="0">
-                <a:solidFill>
-                  <a:srgbClr val="212A33"/>
-                </a:solidFill>
-                <a:latin typeface="Calibri"/>
-                <a:ea typeface="Calibri"/>
-                <a:cs typeface="Calibri"/>
-              </a:rPr>
-              <a:t>760 deterministic grid cells: 401 no-effect; 334 robust improvements; 18 excessive-disclosure flags; 3 larger-gap; 66 multiple CCAR BNE. Diagnostics overlap.</a:t>
-            </a:r>
-          </a:p>
-          <a:p xmlns:a="http://schemas.openxmlformats.org/drawingml/2006/main">
-            <a:pPr algn="l">
-              <a:buNone/>
-              <a:defRPr sz="2400" b="0">
-                <a:solidFill>
-                  <a:srgbClr val="212A33"/>
-                </a:solidFill>
-                <a:latin typeface="Calibri"/>
-                <a:ea typeface="Calibri"/>
-                <a:cs typeface="Calibri"/>
-              </a:defRPr>
-            </a:pPr>
-            <a:r>
-              <a:rPr sz="2400" b="0">
-                <a:solidFill>
-                  <a:srgbClr val="212A33"/>
-                </a:solidFill>
-                <a:latin typeface="Calibri"/>
-                <a:ea typeface="Calibri"/>
-                <a:cs typeface="Calibri"/>
-              </a:rPr>
-              <a:t>Verification: outputs/final/; exhaustive 81-profile search. Evidence: stylized computation.</a:t>
-            </a:r>
-          </a:p>
-        </p:txBody>
-      </p:sp>
-      <p:sp>
-        <p:nvSpPr>
-          <p:cNvPr id="31" name="impact-title">
-            <a:extLst xmlns:a="http://schemas.openxmlformats.org/drawingml/2006/main">
-              <a:ext uri="{FF2B5EF4-FFF2-40B4-BE49-F238E27FC236}">
-                <a16:creationId xmlns:a16="http://schemas.microsoft.com/office/drawing/2014/main" id="{7974BDE9-47C8-4976-9EB0-1D99D2AD436D}"/>
-              </a:ext>
-            </a:extLst>
-          </p:cNvPr>
-          <p:cNvSpPr>
-            <a:spLocks xmlns:a="http://schemas.openxmlformats.org/drawingml/2006/main" noGrp="1"/>
-          </p:cNvSpPr>
-          <p:nvPr/>
-        </p:nvSpPr>
-        <p:spPr>
-          <a:xfrm xmlns:a="http://schemas.openxmlformats.org/drawingml/2006/main">
-            <a:off x="30421500" y="9525000"/>
-            <a:ext cx="11049000" cy="809625"/>
+          <p:cNvPr id="37" name="limits-heading">
+            <a:extLst xmlns:a="http://schemas.openxmlformats.org/drawingml/2006/main">
+              <a:ext uri="{FF2B5EF4-FFF2-40B4-BE49-F238E27FC236}">
+                <a16:creationId xmlns:a16="http://schemas.microsoft.com/office/drawing/2014/main" id="{68ADFBED-634F-4EFD-A437-EF921500A3B3}"/>
+              </a:ext>
+            </a:extLst>
+          </p:cNvPr>
+          <p:cNvSpPr>
+            <a:spLocks xmlns:a="http://schemas.openxmlformats.org/drawingml/2006/main" noGrp="1"/>
+          </p:cNvSpPr>
+          <p:nvPr/>
+        </p:nvSpPr>
+        <p:spPr>
+          <a:xfrm xmlns:a="http://schemas.openxmlformats.org/drawingml/2006/main">
+            <a:off x="31242000" y="22240875"/>
+            <a:ext cx="10229850" cy="666750"/>
           </a:xfrm>
           <a:prstGeom xmlns:a="http://schemas.openxmlformats.org/drawingml/2006/main" prst="rect">
             <a:avLst/>
@@ -2915,7 +3541,7 @@
           <a:p xmlns:a="http://schemas.openxmlformats.org/drawingml/2006/main">
             <a:pPr algn="l">
               <a:buNone/>
-              <a:defRPr sz="4650" b="1">
+              <a:defRPr sz="3375" b="1">
                 <a:solidFill>
                   <a:srgbClr val="003399"/>
                 </a:solidFill>
@@ -2925,7 +3551,7 @@
               </a:defRPr>
             </a:pPr>
             <a:r>
-              <a:rPr sz="4650" b="1">
+              <a:rPr sz="3375" b="1">
                 <a:solidFill>
                   <a:srgbClr val="003399"/>
                 </a:solidFill>
@@ -2933,347 +3559,13 @@
                 <a:ea typeface="Calibri"/>
                 <a:cs typeface="Calibri"/>
               </a:rPr>
-              <a:t>03   Practical impacts and roadmap</a:t>
+              <a:t>Integration and updated named contributions</a:t>
             </a:r>
           </a:p>
         </p:txBody>
       </p:sp>
       <p:sp>
         <p:nvSpPr>
-          <p:cNvPr id="32" name="impact-title-rule">
-            <a:extLst xmlns:a="http://schemas.openxmlformats.org/drawingml/2006/main">
-              <a:ext uri="{FF2B5EF4-FFF2-40B4-BE49-F238E27FC236}">
-                <a16:creationId xmlns:a16="http://schemas.microsoft.com/office/drawing/2014/main" id="{92EF0681-32CB-4E92-B477-91FDD7DB084E}"/>
-              </a:ext>
-            </a:extLst>
-          </p:cNvPr>
-          <p:cNvSpPr>
-            <a:spLocks xmlns:a="http://schemas.openxmlformats.org/drawingml/2006/main" noGrp="1"/>
-          </p:cNvSpPr>
-          <p:nvPr/>
-        </p:nvSpPr>
-        <p:spPr>
-          <a:xfrm xmlns:a="http://schemas.openxmlformats.org/drawingml/2006/main">
-            <a:off x="30421500" y="10506075"/>
-            <a:ext cx="11049000" cy="47625"/>
-          </a:xfrm>
-          <a:prstGeom xmlns:a="http://schemas.openxmlformats.org/drawingml/2006/main" prst="rect">
-            <a:avLst/>
-          </a:prstGeom>
-          <a:solidFill xmlns:a="http://schemas.openxmlformats.org/drawingml/2006/main">
-            <a:srgbClr val="006633"/>
-          </a:solidFill>
-          <a:ln xmlns:a="http://schemas.openxmlformats.org/drawingml/2006/main" w="0">
-            <a:noFill/>
-            <a:prstDash val="solid"/>
-          </a:ln>
-        </p:spPr>
-      </p:sp>
-      <p:sp>
-        <p:nvSpPr>
-          <p:cNvPr id="33" name="real-world-heading">
-            <a:extLst xmlns:a="http://schemas.openxmlformats.org/drawingml/2006/main">
-              <a:ext uri="{FF2B5EF4-FFF2-40B4-BE49-F238E27FC236}">
-                <a16:creationId xmlns:a16="http://schemas.microsoft.com/office/drawing/2014/main" id="{8D7A544D-17E0-43AC-A769-0DC992E2E072}"/>
-              </a:ext>
-            </a:extLst>
-          </p:cNvPr>
-          <p:cNvSpPr>
-            <a:spLocks xmlns:a="http://schemas.openxmlformats.org/drawingml/2006/main" noGrp="1"/>
-          </p:cNvSpPr>
-          <p:nvPr/>
-        </p:nvSpPr>
-        <p:spPr>
-          <a:xfrm xmlns:a="http://schemas.openxmlformats.org/drawingml/2006/main">
-            <a:off x="30421500" y="11144250"/>
-            <a:ext cx="11049000" cy="666750"/>
-          </a:xfrm>
-          <a:prstGeom xmlns:a="http://schemas.openxmlformats.org/drawingml/2006/main" prst="rect">
-            <a:avLst/>
-          </a:prstGeom>
-          <a:noFill xmlns:a="http://schemas.openxmlformats.org/drawingml/2006/main"/>
-          <a:ln xmlns:a="http://schemas.openxmlformats.org/drawingml/2006/main" w="0">
-            <a:noFill/>
-            <a:prstDash val="solid"/>
-          </a:ln>
-        </p:spPr>
-        <p:txBody>
-          <a:bodyPr xmlns:a="http://schemas.openxmlformats.org/drawingml/2006/main">
-            <a:noAutofit/>
-          </a:bodyPr>
-          <a:lstStyle xmlns:a="http://schemas.openxmlformats.org/drawingml/2006/main"/>
-          <a:p xmlns:a="http://schemas.openxmlformats.org/drawingml/2006/main">
-            <a:pPr algn="l">
-              <a:buNone/>
-              <a:defRPr sz="3375" b="1">
-                <a:solidFill>
-                  <a:srgbClr val="003399"/>
-                </a:solidFill>
-                <a:latin typeface="Calibri"/>
-                <a:ea typeface="Calibri"/>
-                <a:cs typeface="Calibri"/>
-              </a:defRPr>
-            </a:pPr>
-            <a:r>
-              <a:rPr sz="3375" b="1">
-                <a:solidFill>
-                  <a:srgbClr val="003399"/>
-                </a:solidFill>
-                <a:latin typeface="Calibri"/>
-                <a:ea typeface="Calibri"/>
-                <a:cs typeface="Calibri"/>
-              </a:rPr>
-              <a:t>Practical Impacts diagram with SDG targets</a:t>
-            </a:r>
-          </a:p>
-        </p:txBody>
-      </p:sp>
-      <p:sp>
-        <p:nvSpPr>
-          <p:cNvPr id="34" name="real-world">
-            <a:extLst xmlns:a="http://schemas.openxmlformats.org/drawingml/2006/main">
-              <a:ext uri="{FF2B5EF4-FFF2-40B4-BE49-F238E27FC236}">
-                <a16:creationId xmlns:a16="http://schemas.microsoft.com/office/drawing/2014/main" id="{2199F087-3016-48E4-80F0-4F875A71FCDD}"/>
-              </a:ext>
-            </a:extLst>
-          </p:cNvPr>
-          <p:cNvSpPr>
-            <a:spLocks xmlns:a="http://schemas.openxmlformats.org/drawingml/2006/main" noGrp="1"/>
-          </p:cNvSpPr>
-          <p:nvPr/>
-        </p:nvSpPr>
-        <p:spPr>
-          <a:xfrm xmlns:a="http://schemas.openxmlformats.org/drawingml/2006/main">
-            <a:off x="30421500" y="11906250"/>
-            <a:ext cx="11049000" cy="3571875"/>
-          </a:xfrm>
-          <a:prstGeom xmlns:a="http://schemas.openxmlformats.org/drawingml/2006/main" prst="rect">
-            <a:avLst/>
-          </a:prstGeom>
-          <a:noFill xmlns:a="http://schemas.openxmlformats.org/drawingml/2006/main"/>
-          <a:ln xmlns:a="http://schemas.openxmlformats.org/drawingml/2006/main" w="0">
-            <a:noFill/>
-            <a:prstDash val="solid"/>
-          </a:ln>
-        </p:spPr>
-        <p:txBody>
-          <a:bodyPr xmlns:a="http://schemas.openxmlformats.org/drawingml/2006/main">
-            <a:noAutofit/>
-          </a:bodyPr>
-          <a:lstStyle xmlns:a="http://schemas.openxmlformats.org/drawingml/2006/main">
-            <a:defPPr>
-              <a:defRPr sz="2250"/>
-            </a:defPPr>
-          </a:lstStyle>
-          <a:p xmlns:a="http://schemas.openxmlformats.org/drawingml/2006/main">
-            <a:pPr algn="l">
-              <a:buNone/>
-              <a:defRPr sz="3300" b="0">
-                <a:solidFill>
-                  <a:srgbClr val="212A33"/>
-                </a:solidFill>
-                <a:latin typeface="Calibri"/>
-                <a:ea typeface="Calibri"/>
-                <a:cs typeface="Calibri"/>
-              </a:defRPr>
-            </a:pPr>
-            <a:r>
-              <a:rPr sz="3300" b="0">
-                <a:solidFill>
-                  <a:srgbClr val="212A33"/>
-                </a:solidFill>
-                <a:latin typeface="Calibri"/>
-                <a:ea typeface="Calibri"/>
-                <a:cs typeface="Calibri"/>
-              </a:rPr>
-              <a:t/>
-            </a:r>
-          </a:p>
-        </p:txBody>
-      </p:sp>
-      <p:sp>
-        <p:nvSpPr>
-          <p:cNvPr id="35" name="interdisciplinary-heading">
-            <a:extLst xmlns:a="http://schemas.openxmlformats.org/drawingml/2006/main">
-              <a:ext uri="{FF2B5EF4-FFF2-40B4-BE49-F238E27FC236}">
-                <a16:creationId xmlns:a16="http://schemas.microsoft.com/office/drawing/2014/main" id="{1E996ED0-A32A-4617-8E65-E6ED026E62D8}"/>
-              </a:ext>
-            </a:extLst>
-          </p:cNvPr>
-          <p:cNvSpPr>
-            <a:spLocks xmlns:a="http://schemas.openxmlformats.org/drawingml/2006/main" noGrp="1"/>
-          </p:cNvSpPr>
-          <p:nvPr/>
-        </p:nvSpPr>
-        <p:spPr>
-          <a:xfrm xmlns:a="http://schemas.openxmlformats.org/drawingml/2006/main">
-            <a:off x="30421500" y="15811500"/>
-            <a:ext cx="11049000" cy="666750"/>
-          </a:xfrm>
-          <a:prstGeom xmlns:a="http://schemas.openxmlformats.org/drawingml/2006/main" prst="rect">
-            <a:avLst/>
-          </a:prstGeom>
-          <a:noFill xmlns:a="http://schemas.openxmlformats.org/drawingml/2006/main"/>
-          <a:ln xmlns:a="http://schemas.openxmlformats.org/drawingml/2006/main" w="0">
-            <a:noFill/>
-            <a:prstDash val="solid"/>
-          </a:ln>
-        </p:spPr>
-        <p:txBody>
-          <a:bodyPr xmlns:a="http://schemas.openxmlformats.org/drawingml/2006/main">
-            <a:noAutofit/>
-          </a:bodyPr>
-          <a:lstStyle xmlns:a="http://schemas.openxmlformats.org/drawingml/2006/main"/>
-          <a:p xmlns:a="http://schemas.openxmlformats.org/drawingml/2006/main">
-            <a:pPr algn="l">
-              <a:buNone/>
-              <a:defRPr sz="3375" b="1">
-                <a:solidFill>
-                  <a:srgbClr val="003399"/>
-                </a:solidFill>
-                <a:latin typeface="Calibri"/>
-                <a:ea typeface="Calibri"/>
-                <a:cs typeface="Calibri"/>
-              </a:defRPr>
-            </a:pPr>
-            <a:r>
-              <a:rPr sz="3375" b="1">
-                <a:solidFill>
-                  <a:srgbClr val="003399"/>
-                </a:solidFill>
-                <a:latin typeface="Calibri"/>
-                <a:ea typeface="Calibri"/>
-                <a:cs typeface="Calibri"/>
-              </a:rPr>
-              <a:t>Future Research Roadmap new diagram</a:t>
-            </a:r>
-          </a:p>
-        </p:txBody>
-      </p:sp>
-      <p:sp>
-        <p:nvSpPr>
-          <p:cNvPr id="36" name="interdisciplinary">
-            <a:extLst xmlns:a="http://schemas.openxmlformats.org/drawingml/2006/main">
-              <a:ext uri="{FF2B5EF4-FFF2-40B4-BE49-F238E27FC236}">
-                <a16:creationId xmlns:a16="http://schemas.microsoft.com/office/drawing/2014/main" id="{91D1D813-AECB-4965-9667-285D2DDCB3E4}"/>
-              </a:ext>
-            </a:extLst>
-          </p:cNvPr>
-          <p:cNvSpPr>
-            <a:spLocks xmlns:a="http://schemas.openxmlformats.org/drawingml/2006/main" noGrp="1"/>
-          </p:cNvSpPr>
-          <p:nvPr/>
-        </p:nvSpPr>
-        <p:spPr>
-          <a:xfrm xmlns:a="http://schemas.openxmlformats.org/drawingml/2006/main">
-            <a:off x="30421500" y="16573500"/>
-            <a:ext cx="11049000" cy="5238750"/>
-          </a:xfrm>
-          <a:prstGeom xmlns:a="http://schemas.openxmlformats.org/drawingml/2006/main" prst="rect">
-            <a:avLst/>
-          </a:prstGeom>
-          <a:noFill xmlns:a="http://schemas.openxmlformats.org/drawingml/2006/main"/>
-          <a:ln xmlns:a="http://schemas.openxmlformats.org/drawingml/2006/main" w="0">
-            <a:noFill/>
-            <a:prstDash val="solid"/>
-          </a:ln>
-        </p:spPr>
-        <p:txBody>
-          <a:bodyPr xmlns:a="http://schemas.openxmlformats.org/drawingml/2006/main">
-            <a:noAutofit/>
-          </a:bodyPr>
-          <a:lstStyle xmlns:a="http://schemas.openxmlformats.org/drawingml/2006/main">
-            <a:defPPr>
-              <a:defRPr sz="2250"/>
-            </a:defPPr>
-          </a:lstStyle>
-          <a:p xmlns:a="http://schemas.openxmlformats.org/drawingml/2006/main">
-            <a:pPr algn="l">
-              <a:buNone/>
-              <a:defRPr sz="3225" b="0">
-                <a:solidFill>
-                  <a:srgbClr val="212A33"/>
-                </a:solidFill>
-                <a:latin typeface="Calibri"/>
-                <a:ea typeface="Calibri"/>
-                <a:cs typeface="Calibri"/>
-              </a:defRPr>
-            </a:pPr>
-            <a:r>
-              <a:rPr sz="3225" b="0">
-                <a:solidFill>
-                  <a:srgbClr val="212A33"/>
-                </a:solidFill>
-                <a:latin typeface="Calibri"/>
-                <a:ea typeface="Calibri"/>
-                <a:cs typeface="Calibri"/>
-              </a:rPr>
-              <a:t/>
-            </a:r>
-          </a:p>
-        </p:txBody>
-      </p:sp>
-      <p:sp>
-        <p:nvSpPr>
-          <p:cNvPr id="37" name="limits-heading">
-            <a:extLst xmlns:a="http://schemas.openxmlformats.org/drawingml/2006/main">
-              <a:ext uri="{FF2B5EF4-FFF2-40B4-BE49-F238E27FC236}">
-                <a16:creationId xmlns:a16="http://schemas.microsoft.com/office/drawing/2014/main" id="{68ADFBED-634F-4EFD-A437-EF921500A3B3}"/>
-              </a:ext>
-            </a:extLst>
-          </p:cNvPr>
-          <p:cNvSpPr>
-            <a:spLocks xmlns:a="http://schemas.openxmlformats.org/drawingml/2006/main" noGrp="1"/>
-          </p:cNvSpPr>
-          <p:nvPr/>
-        </p:nvSpPr>
-        <p:spPr>
-          <a:xfrm xmlns:a="http://schemas.openxmlformats.org/drawingml/2006/main">
-            <a:off x="30421500" y="22193250"/>
-            <a:ext cx="11049000" cy="666750"/>
-          </a:xfrm>
-          <a:prstGeom xmlns:a="http://schemas.openxmlformats.org/drawingml/2006/main" prst="rect">
-            <a:avLst/>
-          </a:prstGeom>
-          <a:noFill xmlns:a="http://schemas.openxmlformats.org/drawingml/2006/main"/>
-          <a:ln xmlns:a="http://schemas.openxmlformats.org/drawingml/2006/main" w="0">
-            <a:noFill/>
-            <a:prstDash val="solid"/>
-          </a:ln>
-        </p:spPr>
-        <p:txBody>
-          <a:bodyPr xmlns:a="http://schemas.openxmlformats.org/drawingml/2006/main">
-            <a:noAutofit/>
-          </a:bodyPr>
-          <a:lstStyle xmlns:a="http://schemas.openxmlformats.org/drawingml/2006/main"/>
-          <a:p xmlns:a="http://schemas.openxmlformats.org/drawingml/2006/main">
-            <a:pPr algn="l">
-              <a:buNone/>
-              <a:defRPr sz="3375" b="1">
-                <a:solidFill>
-                  <a:srgbClr val="003399"/>
-                </a:solidFill>
-                <a:latin typeface="Calibri"/>
-                <a:ea typeface="Calibri"/>
-                <a:cs typeface="Calibri"/>
-              </a:defRPr>
-            </a:pPr>
-            <a:r>
-              <a:rPr sz="3375" b="1">
-                <a:solidFill>
-                  <a:srgbClr val="003399"/>
-                </a:solidFill>
-                <a:latin typeface="Calibri"/>
-                <a:ea typeface="Calibri"/>
-                <a:cs typeface="Calibri"/>
-              </a:rPr>
-              <a:t>Integration and updated named contributions</a:t>
-            </a:r>
-          </a:p>
-        </p:txBody>
-      </p:sp>
-      <p:sp>
-        <p:nvSpPr>
           <p:cNvPr id="38" name="limits">
             <a:extLst xmlns:a="http://schemas.openxmlformats.org/drawingml/2006/main">
               <a:ext uri="{FF2B5EF4-FFF2-40B4-BE49-F238E27FC236}">
@@ -3288,8 +3580,8 @@
         </p:nvSpPr>
         <p:spPr>
           <a:xfrm xmlns:a="http://schemas.openxmlformats.org/drawingml/2006/main">
-            <a:off x="30421500" y="22955250"/>
-            <a:ext cx="11049000" cy="2619375"/>
+            <a:off x="31242000" y="22955250"/>
+            <a:ext cx="10229850" cy="2571750"/>
           </a:xfrm>
           <a:prstGeom xmlns:a="http://schemas.openxmlformats.org/drawingml/2006/main" prst="rect">
             <a:avLst/>
@@ -3399,8 +3691,8 @@
         </p:nvSpPr>
         <p:spPr>
           <a:xfrm xmlns:a="http://schemas.openxmlformats.org/drawingml/2006/main">
-            <a:off x="30421500" y="25812750"/>
-            <a:ext cx="11049000" cy="1143000"/>
+            <a:off x="31242000" y="25717500"/>
+            <a:ext cx="10229850" cy="1238250"/>
           </a:xfrm>
           <a:prstGeom xmlns:a="http://schemas.openxmlformats.org/drawingml/2006/main" prst="rect">
             <a:avLst/>
@@ -4243,7 +4535,7 @@
           <p:cNvPr id="59" name="">
             <a:extLst xmlns:a="http://schemas.openxmlformats.org/drawingml/2006/main">
               <a:ext uri="{FF2B5EF4-FFF2-40B4-BE49-F238E27FC236}">
-                <a16:creationId xmlns:a16="http://schemas.microsoft.com/office/drawing/2014/main" id="{6C6CC7FF-1699-4F15-947E-BF5682BC4C8C}"/>
+                <a16:creationId xmlns:a16="http://schemas.microsoft.com/office/drawing/2014/main" id="{00DAD0B9-87EB-4561-9D4D-41AA9BF84CF0}"/>
               </a:ext>
             </a:extLst>
           </p:cNvPr>
@@ -4253,13 +4545,13 @@
           <p:nvPr/>
         </p:nvPicPr>
         <p:blipFill>
-          <a:blip xmlns:r="http://schemas.openxmlformats.org/officeDocument/2006/relationships" xmlns:a="http://schemas.openxmlformats.org/drawingml/2006/main" r:embed="Rf84def3742b94c92"/>
+          <a:blip xmlns:r="http://schemas.openxmlformats.org/officeDocument/2006/relationships" xmlns:a="http://schemas.openxmlformats.org/drawingml/2006/main" r:embed="Ra2aeb8bac70a4159"/>
           <a:stretch xmlns:a="http://schemas.openxmlformats.org/drawingml/2006/main"/>
         </p:blipFill>
         <p:spPr>
           <a:xfrm xmlns:a="http://schemas.openxmlformats.org/drawingml/2006/main">
-            <a:off x="13677572" y="11144250"/>
-            <a:ext cx="15450207" cy="4667250"/>
+            <a:off x="12525375" y="11239996"/>
+            <a:ext cx="17811750" cy="5380633"/>
           </a:xfrm>
           <a:prstGeom xmlns:a="http://schemas.openxmlformats.org/drawingml/2006/main" prst="rect">
             <a:avLst/>
@@ -4271,7 +4563,7 @@
           <p:cNvPr id="61" name="">
             <a:extLst xmlns:a="http://schemas.openxmlformats.org/drawingml/2006/main">
               <a:ext uri="{FF2B5EF4-FFF2-40B4-BE49-F238E27FC236}">
-                <a16:creationId xmlns:a16="http://schemas.microsoft.com/office/drawing/2014/main" id="{DE895FD6-40EC-4200-8E86-62F7C8D35119}"/>
+                <a16:creationId xmlns:a16="http://schemas.microsoft.com/office/drawing/2014/main" id="{F3D8EC84-1B02-4035-A964-8A546E25064D}"/>
               </a:ext>
             </a:extLst>
           </p:cNvPr>
@@ -4281,13 +4573,13 @@
           <p:nvPr/>
         </p:nvPicPr>
         <p:blipFill>
-          <a:blip xmlns:r="http://schemas.openxmlformats.org/officeDocument/2006/relationships" xmlns:a="http://schemas.openxmlformats.org/drawingml/2006/main" r:embed="Re34c04a845674878"/>
+          <a:blip xmlns:r="http://schemas.openxmlformats.org/officeDocument/2006/relationships" xmlns:a="http://schemas.openxmlformats.org/drawingml/2006/main" r:embed="Rd4caccfef9664c80"/>
           <a:stretch xmlns:a="http://schemas.openxmlformats.org/drawingml/2006/main"/>
         </p:blipFill>
         <p:spPr>
           <a:xfrm xmlns:a="http://schemas.openxmlformats.org/drawingml/2006/main">
-            <a:off x="16300721" y="17954625"/>
-            <a:ext cx="10165808" cy="5619750"/>
+            <a:off x="12697290" y="17859375"/>
+            <a:ext cx="11371921" cy="6286500"/>
           </a:xfrm>
           <a:prstGeom xmlns:a="http://schemas.openxmlformats.org/drawingml/2006/main" prst="rect">
             <a:avLst/>
@@ -4299,7 +4591,7 @@
           <p:cNvPr id="62" name="">
             <a:extLst xmlns:a="http://schemas.openxmlformats.org/drawingml/2006/main">
               <a:ext uri="{FF2B5EF4-FFF2-40B4-BE49-F238E27FC236}">
-                <a16:creationId xmlns:a16="http://schemas.microsoft.com/office/drawing/2014/main" id="{020A0FC6-858E-4703-9338-33B21C210C70}"/>
+                <a16:creationId xmlns:a16="http://schemas.microsoft.com/office/drawing/2014/main" id="{0F30538A-26AC-4573-9A40-9034B70FA857}"/>
               </a:ext>
             </a:extLst>
           </p:cNvPr>
@@ -4309,13 +4601,13 @@
           <p:nvPr/>
         </p:nvPicPr>
         <p:blipFill>
-          <a:blip xmlns:r="http://schemas.openxmlformats.org/officeDocument/2006/relationships" xmlns:a="http://schemas.openxmlformats.org/drawingml/2006/main" r:embed="R80ab41f6929c427e"/>
+          <a:blip xmlns:r="http://schemas.openxmlformats.org/officeDocument/2006/relationships" xmlns:a="http://schemas.openxmlformats.org/drawingml/2006/main" r:embed="R16c5da65304345d8"/>
           <a:stretch xmlns:a="http://schemas.openxmlformats.org/drawingml/2006/main"/>
         </p:blipFill>
         <p:spPr>
           <a:xfrm xmlns:a="http://schemas.openxmlformats.org/drawingml/2006/main">
-            <a:off x="32593492" y="11858625"/>
-            <a:ext cx="6688667" cy="3762375"/>
+            <a:off x="32546925" y="11858625"/>
+            <a:ext cx="7620000" cy="4286250"/>
           </a:xfrm>
           <a:prstGeom xmlns:a="http://schemas.openxmlformats.org/drawingml/2006/main" prst="rect">
             <a:avLst/>
@@ -4327,7 +4619,7 @@
           <p:cNvPr id="63" name="">
             <a:extLst xmlns:a="http://schemas.openxmlformats.org/drawingml/2006/main">
               <a:ext uri="{FF2B5EF4-FFF2-40B4-BE49-F238E27FC236}">
-                <a16:creationId xmlns:a16="http://schemas.microsoft.com/office/drawing/2014/main" id="{7664871F-787C-47F4-99AB-606432105483}"/>
+                <a16:creationId xmlns:a16="http://schemas.microsoft.com/office/drawing/2014/main" id="{51B81611-AAB4-47C6-B493-6DEEE75AB5E9}"/>
               </a:ext>
             </a:extLst>
           </p:cNvPr>
@@ -4337,13 +4629,13 @@
           <p:nvPr/>
         </p:nvPicPr>
         <p:blipFill>
-          <a:blip xmlns:r="http://schemas.openxmlformats.org/officeDocument/2006/relationships" xmlns:a="http://schemas.openxmlformats.org/drawingml/2006/main" r:embed="R162c5221418347ae"/>
+          <a:blip xmlns:r="http://schemas.openxmlformats.org/officeDocument/2006/relationships" xmlns:a="http://schemas.openxmlformats.org/drawingml/2006/main" r:embed="R6662c1f210f74f56"/>
           <a:stretch xmlns:a="http://schemas.openxmlformats.org/drawingml/2006/main"/>
         </p:blipFill>
         <p:spPr>
           <a:xfrm xmlns:a="http://schemas.openxmlformats.org/drawingml/2006/main">
-            <a:off x="31154158" y="16525875"/>
-            <a:ext cx="9567333" cy="5381625"/>
+            <a:off x="31954258" y="17097375"/>
+            <a:ext cx="8805333" cy="4953000"/>
           </a:xfrm>
           <a:prstGeom xmlns:a="http://schemas.openxmlformats.org/drawingml/2006/main" prst="rect">
             <a:avLst/>
@@ -4355,7 +4647,7 @@
           <p:cNvPr id="64" name="">
             <a:extLst xmlns:a="http://schemas.openxmlformats.org/drawingml/2006/main">
               <a:ext uri="{FF2B5EF4-FFF2-40B4-BE49-F238E27FC236}">
-                <a16:creationId xmlns:a16="http://schemas.microsoft.com/office/drawing/2014/main" id="{4D67A49A-46D6-4D6A-91E2-EC7AE3B9EFB0}"/>
+                <a16:creationId xmlns:a16="http://schemas.microsoft.com/office/drawing/2014/main" id="{934DC889-BF67-4239-A55C-CBF5C9B12645}"/>
               </a:ext>
             </a:extLst>
           </p:cNvPr>
@@ -4365,7 +4657,7 @@
           <p:nvPr/>
         </p:nvPicPr>
         <p:blipFill>
-          <a:blip xmlns:r="http://schemas.openxmlformats.org/officeDocument/2006/relationships" xmlns:a="http://schemas.openxmlformats.org/drawingml/2006/main" r:embed="R9aff81d92c574c23"/>
+          <a:blip xmlns:r="http://schemas.openxmlformats.org/officeDocument/2006/relationships" xmlns:a="http://schemas.openxmlformats.org/drawingml/2006/main" r:embed="Rf0757bb09d644c76"/>
           <a:stretch xmlns:a="http://schemas.openxmlformats.org/drawingml/2006/main"/>
         </p:blipFill>
         <p:spPr>
@@ -4383,7 +4675,7 @@
           <p:cNvPr id="65" name="">
             <a:extLst xmlns:a="http://schemas.openxmlformats.org/drawingml/2006/main">
               <a:ext uri="{FF2B5EF4-FFF2-40B4-BE49-F238E27FC236}">
-                <a16:creationId xmlns:a16="http://schemas.microsoft.com/office/drawing/2014/main" id="{83C5D2E9-C42D-4171-BFAD-BE57C976F075}"/>
+                <a16:creationId xmlns:a16="http://schemas.microsoft.com/office/drawing/2014/main" id="{2F279C91-369B-4358-96DD-4C071ABB96DE}"/>
               </a:ext>
             </a:extLst>
           </p:cNvPr>
@@ -4393,7 +4685,7 @@
           <p:nvPr/>
         </p:nvPicPr>
         <p:blipFill>
-          <a:blip xmlns:r="http://schemas.openxmlformats.org/officeDocument/2006/relationships" xmlns:a="http://schemas.openxmlformats.org/drawingml/2006/main" r:embed="Raf263ad0289648c5"/>
+          <a:blip xmlns:r="http://schemas.openxmlformats.org/officeDocument/2006/relationships" xmlns:a="http://schemas.openxmlformats.org/drawingml/2006/main" r:embed="R1edd55b1a92643ee"/>
           <a:stretch xmlns:a="http://schemas.openxmlformats.org/drawingml/2006/main"/>
         </p:blipFill>
         <p:spPr>
@@ -4411,23 +4703,23 @@
           <p:cNvPr id="66" name="">
             <a:extLst xmlns:a="http://schemas.openxmlformats.org/drawingml/2006/main">
               <a:ext uri="{FF2B5EF4-FFF2-40B4-BE49-F238E27FC236}">
-                <a16:creationId xmlns:a16="http://schemas.microsoft.com/office/drawing/2014/main" id="{D10FD903-DBA1-45A6-822A-090F9BA36202}"/>
-              </a:ext>
-            </a:extLst>
-          </p:cNvPr>
-          <p:cNvSpPr>
-            <a:spLocks xmlns:a="http://schemas.openxmlformats.org/drawingml/2006/main" noGrp="1"/>
-          </p:cNvSpPr>
-          <p:nvPr/>
-        </p:nvSpPr>
-        <p:spPr>
-          <a:xfrm xmlns:a="http://schemas.openxmlformats.org/drawingml/2006/main">
-            <a:off x="1428750" y="15859125"/>
-            <a:ext cx="10810875" cy="666750"/>
+                <a16:creationId xmlns:a16="http://schemas.microsoft.com/office/drawing/2014/main" id="{EE25EAE1-413D-4B80-8F50-0AD4BF0CB7EA}"/>
+              </a:ext>
+            </a:extLst>
+          </p:cNvPr>
+          <p:cNvSpPr>
+            <a:spLocks xmlns:a="http://schemas.openxmlformats.org/drawingml/2006/main" noGrp="1"/>
+          </p:cNvSpPr>
+          <p:nvPr/>
+        </p:nvSpPr>
+        <p:spPr>
+          <a:xfrm xmlns:a="http://schemas.openxmlformats.org/drawingml/2006/main">
+            <a:off x="1428750" y="15716250"/>
+            <a:ext cx="10001250" cy="647700"/>
           </a:xfrm>
           <a:prstGeom xmlns:a="http://schemas.openxmlformats.org/drawingml/2006/main" prst="roundRect">
             <a:avLst>
-              <a:gd name="adj" fmla="val 11429"/>
+              <a:gd name="adj" fmla="val 11765"/>
             </a:avLst>
           </a:prstGeom>
           <a:solidFill xmlns:a="http://schemas.openxmlformats.org/drawingml/2006/main">
@@ -4475,23 +4767,23 @@
           <p:cNvPr id="67" name="">
             <a:extLst xmlns:a="http://schemas.openxmlformats.org/drawingml/2006/main">
               <a:ext uri="{FF2B5EF4-FFF2-40B4-BE49-F238E27FC236}">
-                <a16:creationId xmlns:a16="http://schemas.microsoft.com/office/drawing/2014/main" id="{CBC81A1B-00C0-44B1-A77B-740B6E2C7008}"/>
-              </a:ext>
-            </a:extLst>
-          </p:cNvPr>
-          <p:cNvSpPr>
-            <a:spLocks xmlns:a="http://schemas.openxmlformats.org/drawingml/2006/main" noGrp="1"/>
-          </p:cNvSpPr>
-          <p:nvPr/>
-        </p:nvSpPr>
-        <p:spPr>
-          <a:xfrm xmlns:a="http://schemas.openxmlformats.org/drawingml/2006/main">
-            <a:off x="1428750" y="16678275"/>
-            <a:ext cx="10810875" cy="666750"/>
+                <a16:creationId xmlns:a16="http://schemas.microsoft.com/office/drawing/2014/main" id="{259A94B1-6879-409B-98B1-CE5A84B3CA14}"/>
+              </a:ext>
+            </a:extLst>
+          </p:cNvPr>
+          <p:cNvSpPr>
+            <a:spLocks xmlns:a="http://schemas.openxmlformats.org/drawingml/2006/main" noGrp="1"/>
+          </p:cNvSpPr>
+          <p:nvPr/>
+        </p:nvSpPr>
+        <p:spPr>
+          <a:xfrm xmlns:a="http://schemas.openxmlformats.org/drawingml/2006/main">
+            <a:off x="1428750" y="16478250"/>
+            <a:ext cx="10001250" cy="647700"/>
           </a:xfrm>
           <a:prstGeom xmlns:a="http://schemas.openxmlformats.org/drawingml/2006/main" prst="roundRect">
             <a:avLst>
-              <a:gd name="adj" fmla="val 11429"/>
+              <a:gd name="adj" fmla="val 11765"/>
             </a:avLst>
           </a:prstGeom>
           <a:solidFill xmlns:a="http://schemas.openxmlformats.org/drawingml/2006/main">
@@ -4539,23 +4831,23 @@
           <p:cNvPr id="68" name="">
             <a:extLst xmlns:a="http://schemas.openxmlformats.org/drawingml/2006/main">
               <a:ext uri="{FF2B5EF4-FFF2-40B4-BE49-F238E27FC236}">
-                <a16:creationId xmlns:a16="http://schemas.microsoft.com/office/drawing/2014/main" id="{FA5265B2-BD04-45FB-80A1-5126B0ECFA28}"/>
-              </a:ext>
-            </a:extLst>
-          </p:cNvPr>
-          <p:cNvSpPr>
-            <a:spLocks xmlns:a="http://schemas.openxmlformats.org/drawingml/2006/main" noGrp="1"/>
-          </p:cNvSpPr>
-          <p:nvPr/>
-        </p:nvSpPr>
-        <p:spPr>
-          <a:xfrm xmlns:a="http://schemas.openxmlformats.org/drawingml/2006/main">
-            <a:off x="1428750" y="17497425"/>
-            <a:ext cx="10810875" cy="666750"/>
+                <a16:creationId xmlns:a16="http://schemas.microsoft.com/office/drawing/2014/main" id="{B54B111F-844F-4B84-A02F-384BE061600E}"/>
+              </a:ext>
+            </a:extLst>
+          </p:cNvPr>
+          <p:cNvSpPr>
+            <a:spLocks xmlns:a="http://schemas.openxmlformats.org/drawingml/2006/main" noGrp="1"/>
+          </p:cNvSpPr>
+          <p:nvPr/>
+        </p:nvSpPr>
+        <p:spPr>
+          <a:xfrm xmlns:a="http://schemas.openxmlformats.org/drawingml/2006/main">
+            <a:off x="1428750" y="17240250"/>
+            <a:ext cx="10001250" cy="647700"/>
           </a:xfrm>
           <a:prstGeom xmlns:a="http://schemas.openxmlformats.org/drawingml/2006/main" prst="roundRect">
             <a:avLst>
-              <a:gd name="adj" fmla="val 11429"/>
+              <a:gd name="adj" fmla="val 11765"/>
             </a:avLst>
           </a:prstGeom>
           <a:solidFill xmlns:a="http://schemas.openxmlformats.org/drawingml/2006/main">
@@ -4603,23 +4895,23 @@
           <p:cNvPr id="69" name="">
             <a:extLst xmlns:a="http://schemas.openxmlformats.org/drawingml/2006/main">
               <a:ext uri="{FF2B5EF4-FFF2-40B4-BE49-F238E27FC236}">
-                <a16:creationId xmlns:a16="http://schemas.microsoft.com/office/drawing/2014/main" id="{56CB8401-4BE7-4791-B02B-007BF43A60A4}"/>
-              </a:ext>
-            </a:extLst>
-          </p:cNvPr>
-          <p:cNvSpPr>
-            <a:spLocks xmlns:a="http://schemas.openxmlformats.org/drawingml/2006/main" noGrp="1"/>
-          </p:cNvSpPr>
-          <p:nvPr/>
-        </p:nvSpPr>
-        <p:spPr>
-          <a:xfrm xmlns:a="http://schemas.openxmlformats.org/drawingml/2006/main">
-            <a:off x="1428750" y="18316575"/>
-            <a:ext cx="10810875" cy="666750"/>
+                <a16:creationId xmlns:a16="http://schemas.microsoft.com/office/drawing/2014/main" id="{3ED90E2D-3B96-46A6-B764-3905C104639B}"/>
+              </a:ext>
+            </a:extLst>
+          </p:cNvPr>
+          <p:cNvSpPr>
+            <a:spLocks xmlns:a="http://schemas.openxmlformats.org/drawingml/2006/main" noGrp="1"/>
+          </p:cNvSpPr>
+          <p:nvPr/>
+        </p:nvSpPr>
+        <p:spPr>
+          <a:xfrm xmlns:a="http://schemas.openxmlformats.org/drawingml/2006/main">
+            <a:off x="1428750" y="18002250"/>
+            <a:ext cx="10001250" cy="647700"/>
           </a:xfrm>
           <a:prstGeom xmlns:a="http://schemas.openxmlformats.org/drawingml/2006/main" prst="roundRect">
             <a:avLst>
-              <a:gd name="adj" fmla="val 11429"/>
+              <a:gd name="adj" fmla="val 11765"/>
             </a:avLst>
           </a:prstGeom>
           <a:solidFill xmlns:a="http://schemas.openxmlformats.org/drawingml/2006/main">

</xml_diff>

<commit_message>
fix: improve section 02 connector clarity and spacing
</commit_message>
<xml_diff>
--- a/poster/final-poster.pptx
+++ b/poster/final-poster.pptx
@@ -2,13 +2,13 @@
 <file path=ppt/presentation.xml><?xml version="1.0" encoding="utf-8"?>
 <p:presentation xmlns:p="http://schemas.openxmlformats.org/presentationml/2006/main">
   <p:sldMasterIdLst>
-    <p:sldMasterId xmlns:r="http://schemas.openxmlformats.org/officeDocument/2006/relationships" id="2147483648" r:id="R4501415a48d7460a"/>
+    <p:sldMasterId xmlns:r="http://schemas.openxmlformats.org/officeDocument/2006/relationships" id="2147483648" r:id="R13f1d1ccb8b14af5"/>
   </p:sldMasterIdLst>
   <p:notesMasterIdLst>
-    <p:notesMasterId xmlns:r="http://schemas.openxmlformats.org/officeDocument/2006/relationships" r:id="R41ec0170ae704040"/>
+    <p:notesMasterId xmlns:r="http://schemas.openxmlformats.org/officeDocument/2006/relationships" r:id="Re1dc9657ebef4101"/>
   </p:notesMasterIdLst>
   <p:sldIdLst>
-    <p:sldId xmlns:r="http://schemas.openxmlformats.org/officeDocument/2006/relationships" id="256" r:id="Rf6334f3ef7604858"/>
+    <p:sldId xmlns:r="http://schemas.openxmlformats.org/officeDocument/2006/relationships" id="256" r:id="R6363ce9bc67f478f"/>
   </p:sldIdLst>
   <p:sldSz cx="42804000" cy="30276000"/>
   <p:notesSz cx="6858000" cy="9144000"/>
@@ -510,7 +510,7 @@
   </p:cSld>
   <p:clrMap bg1="lt1" tx1="dk1" bg2="lt2" tx2="dk2" accent1="accent1" accent2="accent2" accent3="accent3" accent4="accent4" accent5="accent5" accent6="accent6" hlink="hlink" folHlink="folHlink"/>
   <p:sldLayoutIdLst>
-    <p:sldLayoutId xmlns:r="http://schemas.openxmlformats.org/officeDocument/2006/relationships" id="2147483649" r:id="Rb4380da22b064cb9"/>
+    <p:sldLayoutId xmlns:r="http://schemas.openxmlformats.org/officeDocument/2006/relationships" id="2147483649" r:id="Rfcb2fae8b0e34f0e"/>
   </p:sldLayoutIdLst>
   <p:txStyles>
     <p:titleStyle>
@@ -1423,7 +1423,7 @@
           <p:cNvPr id="58" name="">
             <a:extLst xmlns:a="http://schemas.openxmlformats.org/drawingml/2006/main">
               <a:ext uri="{FF2B5EF4-FFF2-40B4-BE49-F238E27FC236}">
-                <a16:creationId xmlns:a16="http://schemas.microsoft.com/office/drawing/2014/main" id="{3ABC98D8-729C-44F7-A80B-78D13D8305CE}"/>
+                <a16:creationId xmlns:a16="http://schemas.microsoft.com/office/drawing/2014/main" id="{A82AE401-E09B-4A6E-BB7E-6A9D2BCC9B98}"/>
               </a:ext>
             </a:extLst>
           </p:cNvPr>
@@ -1433,7 +1433,7 @@
           <p:nvPr/>
         </p:nvPicPr>
         <p:blipFill>
-          <a:blip xmlns:r="http://schemas.openxmlformats.org/officeDocument/2006/relationships" xmlns:a="http://schemas.openxmlformats.org/drawingml/2006/main" r:embed="R318832318d9e4251"/>
+          <a:blip xmlns:r="http://schemas.openxmlformats.org/officeDocument/2006/relationships" xmlns:a="http://schemas.openxmlformats.org/drawingml/2006/main" r:embed="R5db1220e9136457c"/>
           <a:stretch xmlns:a="http://schemas.openxmlformats.org/drawingml/2006/main"/>
         </p:blipFill>
         <p:spPr>
@@ -2404,7 +2404,7 @@
         <p:spPr>
           <a:xfrm xmlns:a="http://schemas.openxmlformats.org/drawingml/2006/main">
             <a:off x="12382500" y="11144250"/>
-            <a:ext cx="18097500" cy="5476875"/>
+            <a:ext cx="18097500" cy="6619875"/>
           </a:xfrm>
           <a:prstGeom xmlns:a="http://schemas.openxmlformats.org/drawingml/2006/main" prst="rect">
             <a:avLst/>
@@ -2562,8 +2562,8 @@
         </p:nvSpPr>
         <p:spPr>
           <a:xfrm xmlns:a="http://schemas.openxmlformats.org/drawingml/2006/main">
-            <a:off x="12382500" y="16764000"/>
-            <a:ext cx="18097500" cy="619125"/>
+            <a:off x="12382500" y="17907000"/>
+            <a:ext cx="18097500" cy="571500"/>
           </a:xfrm>
           <a:prstGeom xmlns:a="http://schemas.openxmlformats.org/drawingml/2006/main" prst="rect">
             <a:avLst/>
@@ -2625,8 +2625,8 @@
         </p:nvSpPr>
         <p:spPr>
           <a:xfrm xmlns:a="http://schemas.openxmlformats.org/drawingml/2006/main">
-            <a:off x="12382500" y="17621250"/>
-            <a:ext cx="12001500" cy="6762750"/>
+            <a:off x="12382500" y="18669000"/>
+            <a:ext cx="12001500" cy="6191250"/>
           </a:xfrm>
           <a:prstGeom xmlns:a="http://schemas.openxmlformats.org/drawingml/2006/main" prst="rect">
             <a:avLst/>
@@ -2658,7 +2658,7 @@
         </p:nvSpPr>
         <p:spPr>
           <a:xfrm xmlns:a="http://schemas.openxmlformats.org/drawingml/2006/main">
-            <a:off x="24669750" y="17621250"/>
+            <a:off x="24669750" y="18669000"/>
             <a:ext cx="5810250" cy="809625"/>
           </a:xfrm>
           <a:prstGeom xmlns:a="http://schemas.openxmlformats.org/drawingml/2006/main" prst="rect">
@@ -2721,8 +2721,8 @@
         </p:nvSpPr>
         <p:spPr>
           <a:xfrm xmlns:a="http://schemas.openxmlformats.org/drawingml/2006/main">
-            <a:off x="24669750" y="18526125"/>
-            <a:ext cx="5810250" cy="8429625"/>
+            <a:off x="24669750" y="19573875"/>
+            <a:ext cx="5810250" cy="7381875"/>
           </a:xfrm>
           <a:prstGeom xmlns:a="http://schemas.openxmlformats.org/drawingml/2006/main" prst="rect">
             <a:avLst/>
@@ -3028,8 +3028,8 @@
         </p:nvSpPr>
         <p:spPr>
           <a:xfrm xmlns:a="http://schemas.openxmlformats.org/drawingml/2006/main">
-            <a:off x="12382500" y="24574500"/>
-            <a:ext cx="12001500" cy="2381250"/>
+            <a:off x="12382500" y="25050750"/>
+            <a:ext cx="12001500" cy="1905000"/>
           </a:xfrm>
           <a:prstGeom xmlns:a="http://schemas.openxmlformats.org/drawingml/2006/main" prst="rect">
             <a:avLst/>
@@ -4535,7 +4535,7 @@
           <p:cNvPr id="59" name="">
             <a:extLst xmlns:a="http://schemas.openxmlformats.org/drawingml/2006/main">
               <a:ext uri="{FF2B5EF4-FFF2-40B4-BE49-F238E27FC236}">
-                <a16:creationId xmlns:a16="http://schemas.microsoft.com/office/drawing/2014/main" id="{00DAD0B9-87EB-4561-9D4D-41AA9BF84CF0}"/>
+                <a16:creationId xmlns:a16="http://schemas.microsoft.com/office/drawing/2014/main" id="{8E277A36-2A2B-413D-B35A-43538A9BBFF6}"/>
               </a:ext>
             </a:extLst>
           </p:cNvPr>
@@ -4545,13 +4545,13 @@
           <p:nvPr/>
         </p:nvPicPr>
         <p:blipFill>
-          <a:blip xmlns:r="http://schemas.openxmlformats.org/officeDocument/2006/relationships" xmlns:a="http://schemas.openxmlformats.org/drawingml/2006/main" r:embed="Ra2aeb8bac70a4159"/>
+          <a:blip xmlns:r="http://schemas.openxmlformats.org/officeDocument/2006/relationships" xmlns:a="http://schemas.openxmlformats.org/drawingml/2006/main" r:embed="R8fb2707af1834725"/>
           <a:stretch xmlns:a="http://schemas.openxmlformats.org/drawingml/2006/main"/>
         </p:blipFill>
         <p:spPr>
           <a:xfrm xmlns:a="http://schemas.openxmlformats.org/drawingml/2006/main">
-            <a:off x="12525375" y="11239996"/>
-            <a:ext cx="17811750" cy="5380633"/>
+            <a:off x="12532461" y="11239500"/>
+            <a:ext cx="17797578" cy="6429375"/>
           </a:xfrm>
           <a:prstGeom xmlns:a="http://schemas.openxmlformats.org/drawingml/2006/main" prst="rect">
             <a:avLst/>
@@ -4563,7 +4563,7 @@
           <p:cNvPr id="61" name="">
             <a:extLst xmlns:a="http://schemas.openxmlformats.org/drawingml/2006/main">
               <a:ext uri="{FF2B5EF4-FFF2-40B4-BE49-F238E27FC236}">
-                <a16:creationId xmlns:a16="http://schemas.microsoft.com/office/drawing/2014/main" id="{F3D8EC84-1B02-4035-A964-8A546E25064D}"/>
+                <a16:creationId xmlns:a16="http://schemas.microsoft.com/office/drawing/2014/main" id="{8B62ADF3-1B69-4FAC-8F21-ED6768A25F92}"/>
               </a:ext>
             </a:extLst>
           </p:cNvPr>
@@ -4573,13 +4573,13 @@
           <p:nvPr/>
         </p:nvPicPr>
         <p:blipFill>
-          <a:blip xmlns:r="http://schemas.openxmlformats.org/officeDocument/2006/relationships" xmlns:a="http://schemas.openxmlformats.org/drawingml/2006/main" r:embed="Rd4caccfef9664c80"/>
+          <a:blip xmlns:r="http://schemas.openxmlformats.org/officeDocument/2006/relationships" xmlns:a="http://schemas.openxmlformats.org/drawingml/2006/main" r:embed="Ra032cb0387374986"/>
           <a:stretch xmlns:a="http://schemas.openxmlformats.org/drawingml/2006/main"/>
         </p:blipFill>
         <p:spPr>
           <a:xfrm xmlns:a="http://schemas.openxmlformats.org/drawingml/2006/main">
-            <a:off x="12697290" y="17859375"/>
-            <a:ext cx="11371921" cy="6286500"/>
+            <a:off x="13214195" y="18907125"/>
+            <a:ext cx="10338110" cy="5715000"/>
           </a:xfrm>
           <a:prstGeom xmlns:a="http://schemas.openxmlformats.org/drawingml/2006/main" prst="rect">
             <a:avLst/>
@@ -4591,7 +4591,7 @@
           <p:cNvPr id="62" name="">
             <a:extLst xmlns:a="http://schemas.openxmlformats.org/drawingml/2006/main">
               <a:ext uri="{FF2B5EF4-FFF2-40B4-BE49-F238E27FC236}">
-                <a16:creationId xmlns:a16="http://schemas.microsoft.com/office/drawing/2014/main" id="{0F30538A-26AC-4573-9A40-9034B70FA857}"/>
+                <a16:creationId xmlns:a16="http://schemas.microsoft.com/office/drawing/2014/main" id="{DA6EC6F9-69B7-407D-94AA-90D121D71E91}"/>
               </a:ext>
             </a:extLst>
           </p:cNvPr>
@@ -4601,7 +4601,7 @@
           <p:nvPr/>
         </p:nvPicPr>
         <p:blipFill>
-          <a:blip xmlns:r="http://schemas.openxmlformats.org/officeDocument/2006/relationships" xmlns:a="http://schemas.openxmlformats.org/drawingml/2006/main" r:embed="R16c5da65304345d8"/>
+          <a:blip xmlns:r="http://schemas.openxmlformats.org/officeDocument/2006/relationships" xmlns:a="http://schemas.openxmlformats.org/drawingml/2006/main" r:embed="R46d6f8d398dc4bca"/>
           <a:stretch xmlns:a="http://schemas.openxmlformats.org/drawingml/2006/main"/>
         </p:blipFill>
         <p:spPr>
@@ -4619,7 +4619,7 @@
           <p:cNvPr id="63" name="">
             <a:extLst xmlns:a="http://schemas.openxmlformats.org/drawingml/2006/main">
               <a:ext uri="{FF2B5EF4-FFF2-40B4-BE49-F238E27FC236}">
-                <a16:creationId xmlns:a16="http://schemas.microsoft.com/office/drawing/2014/main" id="{51B81611-AAB4-47C6-B493-6DEEE75AB5E9}"/>
+                <a16:creationId xmlns:a16="http://schemas.microsoft.com/office/drawing/2014/main" id="{480B5915-12D5-4C7A-8823-3C3B0F937ED3}"/>
               </a:ext>
             </a:extLst>
           </p:cNvPr>
@@ -4629,7 +4629,7 @@
           <p:nvPr/>
         </p:nvPicPr>
         <p:blipFill>
-          <a:blip xmlns:r="http://schemas.openxmlformats.org/officeDocument/2006/relationships" xmlns:a="http://schemas.openxmlformats.org/drawingml/2006/main" r:embed="R6662c1f210f74f56"/>
+          <a:blip xmlns:r="http://schemas.openxmlformats.org/officeDocument/2006/relationships" xmlns:a="http://schemas.openxmlformats.org/drawingml/2006/main" r:embed="R41f8988223b34496"/>
           <a:stretch xmlns:a="http://schemas.openxmlformats.org/drawingml/2006/main"/>
         </p:blipFill>
         <p:spPr>
@@ -4647,7 +4647,7 @@
           <p:cNvPr id="64" name="">
             <a:extLst xmlns:a="http://schemas.openxmlformats.org/drawingml/2006/main">
               <a:ext uri="{FF2B5EF4-FFF2-40B4-BE49-F238E27FC236}">
-                <a16:creationId xmlns:a16="http://schemas.microsoft.com/office/drawing/2014/main" id="{934DC889-BF67-4239-A55C-CBF5C9B12645}"/>
+                <a16:creationId xmlns:a16="http://schemas.microsoft.com/office/drawing/2014/main" id="{287BCD90-1509-4279-9842-DBE55A6ED1B6}"/>
               </a:ext>
             </a:extLst>
           </p:cNvPr>
@@ -4657,7 +4657,7 @@
           <p:nvPr/>
         </p:nvPicPr>
         <p:blipFill>
-          <a:blip xmlns:r="http://schemas.openxmlformats.org/officeDocument/2006/relationships" xmlns:a="http://schemas.openxmlformats.org/drawingml/2006/main" r:embed="Rf0757bb09d644c76"/>
+          <a:blip xmlns:r="http://schemas.openxmlformats.org/officeDocument/2006/relationships" xmlns:a="http://schemas.openxmlformats.org/drawingml/2006/main" r:embed="R18ec70d733c4423c"/>
           <a:stretch xmlns:a="http://schemas.openxmlformats.org/drawingml/2006/main"/>
         </p:blipFill>
         <p:spPr>
@@ -4675,7 +4675,7 @@
           <p:cNvPr id="65" name="">
             <a:extLst xmlns:a="http://schemas.openxmlformats.org/drawingml/2006/main">
               <a:ext uri="{FF2B5EF4-FFF2-40B4-BE49-F238E27FC236}">
-                <a16:creationId xmlns:a16="http://schemas.microsoft.com/office/drawing/2014/main" id="{2F279C91-369B-4358-96DD-4C071ABB96DE}"/>
+                <a16:creationId xmlns:a16="http://schemas.microsoft.com/office/drawing/2014/main" id="{A301D324-A0B1-4305-B77E-66C5942FF3BC}"/>
               </a:ext>
             </a:extLst>
           </p:cNvPr>
@@ -4685,7 +4685,7 @@
           <p:nvPr/>
         </p:nvPicPr>
         <p:blipFill>
-          <a:blip xmlns:r="http://schemas.openxmlformats.org/officeDocument/2006/relationships" xmlns:a="http://schemas.openxmlformats.org/drawingml/2006/main" r:embed="R1edd55b1a92643ee"/>
+          <a:blip xmlns:r="http://schemas.openxmlformats.org/officeDocument/2006/relationships" xmlns:a="http://schemas.openxmlformats.org/drawingml/2006/main" r:embed="Rb55c47e584ae4518"/>
           <a:stretch xmlns:a="http://schemas.openxmlformats.org/drawingml/2006/main"/>
         </p:blipFill>
         <p:spPr>
@@ -4703,7 +4703,7 @@
           <p:cNvPr id="66" name="">
             <a:extLst xmlns:a="http://schemas.openxmlformats.org/drawingml/2006/main">
               <a:ext uri="{FF2B5EF4-FFF2-40B4-BE49-F238E27FC236}">
-                <a16:creationId xmlns:a16="http://schemas.microsoft.com/office/drawing/2014/main" id="{EE25EAE1-413D-4B80-8F50-0AD4BF0CB7EA}"/>
+                <a16:creationId xmlns:a16="http://schemas.microsoft.com/office/drawing/2014/main" id="{CD9DCA2C-570C-48D7-B105-714684D8415B}"/>
               </a:ext>
             </a:extLst>
           </p:cNvPr>
@@ -4767,7 +4767,7 @@
           <p:cNvPr id="67" name="">
             <a:extLst xmlns:a="http://schemas.openxmlformats.org/drawingml/2006/main">
               <a:ext uri="{FF2B5EF4-FFF2-40B4-BE49-F238E27FC236}">
-                <a16:creationId xmlns:a16="http://schemas.microsoft.com/office/drawing/2014/main" id="{259A94B1-6879-409B-98B1-CE5A84B3CA14}"/>
+                <a16:creationId xmlns:a16="http://schemas.microsoft.com/office/drawing/2014/main" id="{30F975CE-631F-4563-824E-3301328ADA87}"/>
               </a:ext>
             </a:extLst>
           </p:cNvPr>
@@ -4831,7 +4831,7 @@
           <p:cNvPr id="68" name="">
             <a:extLst xmlns:a="http://schemas.openxmlformats.org/drawingml/2006/main">
               <a:ext uri="{FF2B5EF4-FFF2-40B4-BE49-F238E27FC236}">
-                <a16:creationId xmlns:a16="http://schemas.microsoft.com/office/drawing/2014/main" id="{B54B111F-844F-4B84-A02F-384BE061600E}"/>
+                <a16:creationId xmlns:a16="http://schemas.microsoft.com/office/drawing/2014/main" id="{3DF4F341-E340-4643-A999-7C41433C3573}"/>
               </a:ext>
             </a:extLst>
           </p:cNvPr>
@@ -4895,7 +4895,7 @@
           <p:cNvPr id="69" name="">
             <a:extLst xmlns:a="http://schemas.openxmlformats.org/drawingml/2006/main">
               <a:ext uri="{FF2B5EF4-FFF2-40B4-BE49-F238E27FC236}">
-                <a16:creationId xmlns:a16="http://schemas.microsoft.com/office/drawing/2014/main" id="{3ED90E2D-3B96-46A6-B764-3905C104639B}"/>
+                <a16:creationId xmlns:a16="http://schemas.microsoft.com/office/drawing/2014/main" id="{6AE4C14E-3334-4DBA-B7B1-3B57E99B7CFF}"/>
               </a:ext>
             </a:extLst>
           </p:cNvPr>

</xml_diff>

<commit_message>
chore: package audited final submission artifacts
</commit_message>
<xml_diff>
--- a/poster/final-poster.pptx
+++ b/poster/final-poster.pptx
@@ -2,13 +2,13 @@
 <file path=ppt/presentation.xml><?xml version="1.0" encoding="utf-8"?>
 <p:presentation xmlns:p="http://schemas.openxmlformats.org/presentationml/2006/main">
   <p:sldMasterIdLst>
-    <p:sldMasterId xmlns:r="http://schemas.openxmlformats.org/officeDocument/2006/relationships" id="2147483648" r:id="R13f1d1ccb8b14af5"/>
+    <p:sldMasterId xmlns:r="http://schemas.openxmlformats.org/officeDocument/2006/relationships" id="2147483648" r:id="R8ff2988472174b43"/>
   </p:sldMasterIdLst>
   <p:notesMasterIdLst>
-    <p:notesMasterId xmlns:r="http://schemas.openxmlformats.org/officeDocument/2006/relationships" r:id="Re1dc9657ebef4101"/>
+    <p:notesMasterId xmlns:r="http://schemas.openxmlformats.org/officeDocument/2006/relationships" r:id="Ref9ddb913d0a43f3"/>
   </p:notesMasterIdLst>
   <p:sldIdLst>
-    <p:sldId xmlns:r="http://schemas.openxmlformats.org/officeDocument/2006/relationships" id="256" r:id="R6363ce9bc67f478f"/>
+    <p:sldId xmlns:r="http://schemas.openxmlformats.org/officeDocument/2006/relationships" id="256" r:id="R333991ea841f42cc"/>
   </p:sldIdLst>
   <p:sldSz cx="42804000" cy="30276000"/>
   <p:notesSz cx="6858000" cy="9144000"/>
@@ -510,7 +510,7 @@
   </p:cSld>
   <p:clrMap bg1="lt1" tx1="dk1" bg2="lt2" tx2="dk2" accent1="accent1" accent2="accent2" accent3="accent3" accent4="accent4" accent5="accent5" accent6="accent6" hlink="hlink" folHlink="folHlink"/>
   <p:sldLayoutIdLst>
-    <p:sldLayoutId xmlns:r="http://schemas.openxmlformats.org/officeDocument/2006/relationships" id="2147483649" r:id="Rfcb2fae8b0e34f0e"/>
+    <p:sldLayoutId xmlns:r="http://schemas.openxmlformats.org/officeDocument/2006/relationships" id="2147483649" r:id="R91cecd2cadb54426"/>
   </p:sldLayoutIdLst>
   <p:txStyles>
     <p:titleStyle>
@@ -1423,7 +1423,7 @@
           <p:cNvPr id="58" name="">
             <a:extLst xmlns:a="http://schemas.openxmlformats.org/drawingml/2006/main">
               <a:ext uri="{FF2B5EF4-FFF2-40B4-BE49-F238E27FC236}">
-                <a16:creationId xmlns:a16="http://schemas.microsoft.com/office/drawing/2014/main" id="{A82AE401-E09B-4A6E-BB7E-6A9D2BCC9B98}"/>
+                <a16:creationId xmlns:a16="http://schemas.microsoft.com/office/drawing/2014/main" id="{77563F34-98C8-463F-AE01-8151784D4333}"/>
               </a:ext>
             </a:extLst>
           </p:cNvPr>
@@ -1433,7 +1433,7 @@
           <p:nvPr/>
         </p:nvPicPr>
         <p:blipFill>
-          <a:blip xmlns:r="http://schemas.openxmlformats.org/officeDocument/2006/relationships" xmlns:a="http://schemas.openxmlformats.org/drawingml/2006/main" r:embed="R5db1220e9136457c"/>
+          <a:blip xmlns:r="http://schemas.openxmlformats.org/officeDocument/2006/relationships" xmlns:a="http://schemas.openxmlformats.org/drawingml/2006/main" r:embed="Rd4fb842653ad4282"/>
           <a:stretch xmlns:a="http://schemas.openxmlformats.org/drawingml/2006/main"/>
         </p:blipFill>
         <p:spPr>
@@ -3646,7 +3646,7 @@
                 <a:ea typeface="Calibri"/>
                 <a:cs typeface="Calibri"/>
               </a:rPr>
-              <a:t>Yiqiao Liu: model boundary, code, experiments, interface, paper and poster; 65 baseline tests and fresh artifact verification.</a:t>
+              <a:t>Yiqiao Liu: model boundary, code, experiments, interface, paper and poster; 70 automated tests and fresh artifact verification.</a:t>
             </a:r>
           </a:p>
           <a:p xmlns:a="http://schemas.openxmlformats.org/drawingml/2006/main">
@@ -3733,7 +3733,7 @@
                 <a:ea typeface="Calibri"/>
                 <a:cs typeface="Calibri"/>
               </a:rPr>
-              <a:t>OCT 12 / OCT 14 historical activity records: author confirmation pending</a:t>
+              <a:t>SEP 28  Superseded-topic review recovered; no current-model validation claimed</a:t>
             </a:r>
           </a:p>
           <a:p xmlns:a="http://schemas.openxmlformats.org/drawingml/2006/main">
@@ -3757,7 +3757,7 @@
                 <a:ea typeface="Calibri"/>
                 <a:cs typeface="Calibri"/>
               </a:rPr>
-              <a:t>OCT 21  Final submission at 23:00 Shanghai</a:t>
+              <a:t>OCT 12 / OCT 14  Primary activity records not recovered</a:t>
             </a:r>
           </a:p>
         </p:txBody>
@@ -3910,7 +3910,7 @@
                 <a:ea typeface="Calibri"/>
                 <a:cs typeface="Calibri"/>
               </a:rPr>
-              <a:t>Prof. Luyao Zhang: course design and official templates. Prof. Kenneth S. (Ken) Rogerson: documented course-workshop context; no direct FP10 review claimed. Han Zhang: proposed three-party oversight extension. Xinrong Sun: novelty, domain, congestion-benefit and CCAR-externality challenges (author-supplied summaries; source records pending). Tencent Shanghai office; Shanghai Science and Technology Museum; COMSCI/ECON 206 classroom community. UN SDG assets; Python/NumPy/Matplotlib/nbclient/Gradio/Playwright/ACM template; OpenAI Codex assistance. Yiqiao Liu remains responsible.</a:t>
+              <a:t>Prof. Luyao Zhang: course design and official templates. Prof. Kenneth S. (Ken) Rogerson: course-workshop context only; no direct FP10 review. Feiyu Li: 28 Sept. review of a superseded topic; no current-model validation. Han Zhang: proposed three-party oversight. Xinrong Sun: author-supplied novelty, domain, congestion-benefit and CCAR-externality challenges; source records pending. Tencent Shanghai office; Shanghai Science and Technology Museum; COMSCI/ECON 206 classroom community. UN SDG assets; Python/NumPy/Matplotlib/nbclient/Gradio/Playwright/ACM; OpenAI Codex. Yiqiao Liu remains responsible.</a:t>
             </a:r>
           </a:p>
         </p:txBody>
@@ -4274,7 +4274,7 @@
                 <a:ea typeface="Calibri"/>
                 <a:cs typeface="Calibri"/>
               </a:rPr>
-              <a:t>Final tested commit: pending final verification commit</a:t>
+              <a:t>Validated source commit: 96a1c3a5276267ff6a039d9a11a3d9c4b2cfce38</a:t>
             </a:r>
           </a:p>
         </p:txBody>
@@ -4535,7 +4535,7 @@
           <p:cNvPr id="59" name="">
             <a:extLst xmlns:a="http://schemas.openxmlformats.org/drawingml/2006/main">
               <a:ext uri="{FF2B5EF4-FFF2-40B4-BE49-F238E27FC236}">
-                <a16:creationId xmlns:a16="http://schemas.microsoft.com/office/drawing/2014/main" id="{8E277A36-2A2B-413D-B35A-43538A9BBFF6}"/>
+                <a16:creationId xmlns:a16="http://schemas.microsoft.com/office/drawing/2014/main" id="{75AAF5E9-0E3C-47B7-82DE-3D1141F40D71}"/>
               </a:ext>
             </a:extLst>
           </p:cNvPr>
@@ -4545,7 +4545,7 @@
           <p:nvPr/>
         </p:nvPicPr>
         <p:blipFill>
-          <a:blip xmlns:r="http://schemas.openxmlformats.org/officeDocument/2006/relationships" xmlns:a="http://schemas.openxmlformats.org/drawingml/2006/main" r:embed="R8fb2707af1834725"/>
+          <a:blip xmlns:r="http://schemas.openxmlformats.org/officeDocument/2006/relationships" xmlns:a="http://schemas.openxmlformats.org/drawingml/2006/main" r:embed="R042cd1f2863a4ca6"/>
           <a:stretch xmlns:a="http://schemas.openxmlformats.org/drawingml/2006/main"/>
         </p:blipFill>
         <p:spPr>
@@ -4563,7 +4563,7 @@
           <p:cNvPr id="61" name="">
             <a:extLst xmlns:a="http://schemas.openxmlformats.org/drawingml/2006/main">
               <a:ext uri="{FF2B5EF4-FFF2-40B4-BE49-F238E27FC236}">
-                <a16:creationId xmlns:a16="http://schemas.microsoft.com/office/drawing/2014/main" id="{8B62ADF3-1B69-4FAC-8F21-ED6768A25F92}"/>
+                <a16:creationId xmlns:a16="http://schemas.microsoft.com/office/drawing/2014/main" id="{2694E423-1906-4E9C-897C-F39FE2EF208F}"/>
               </a:ext>
             </a:extLst>
           </p:cNvPr>
@@ -4573,7 +4573,7 @@
           <p:nvPr/>
         </p:nvPicPr>
         <p:blipFill>
-          <a:blip xmlns:r="http://schemas.openxmlformats.org/officeDocument/2006/relationships" xmlns:a="http://schemas.openxmlformats.org/drawingml/2006/main" r:embed="Ra032cb0387374986"/>
+          <a:blip xmlns:r="http://schemas.openxmlformats.org/officeDocument/2006/relationships" xmlns:a="http://schemas.openxmlformats.org/drawingml/2006/main" r:embed="R64fcfae122be4946"/>
           <a:stretch xmlns:a="http://schemas.openxmlformats.org/drawingml/2006/main"/>
         </p:blipFill>
         <p:spPr>
@@ -4591,7 +4591,7 @@
           <p:cNvPr id="62" name="">
             <a:extLst xmlns:a="http://schemas.openxmlformats.org/drawingml/2006/main">
               <a:ext uri="{FF2B5EF4-FFF2-40B4-BE49-F238E27FC236}">
-                <a16:creationId xmlns:a16="http://schemas.microsoft.com/office/drawing/2014/main" id="{DA6EC6F9-69B7-407D-94AA-90D121D71E91}"/>
+                <a16:creationId xmlns:a16="http://schemas.microsoft.com/office/drawing/2014/main" id="{EC65A4CA-597A-4969-A842-A78CF957DF53}"/>
               </a:ext>
             </a:extLst>
           </p:cNvPr>
@@ -4601,7 +4601,7 @@
           <p:nvPr/>
         </p:nvPicPr>
         <p:blipFill>
-          <a:blip xmlns:r="http://schemas.openxmlformats.org/officeDocument/2006/relationships" xmlns:a="http://schemas.openxmlformats.org/drawingml/2006/main" r:embed="R46d6f8d398dc4bca"/>
+          <a:blip xmlns:r="http://schemas.openxmlformats.org/officeDocument/2006/relationships" xmlns:a="http://schemas.openxmlformats.org/drawingml/2006/main" r:embed="R448728bf934c4ccc"/>
           <a:stretch xmlns:a="http://schemas.openxmlformats.org/drawingml/2006/main"/>
         </p:blipFill>
         <p:spPr>
@@ -4619,7 +4619,7 @@
           <p:cNvPr id="63" name="">
             <a:extLst xmlns:a="http://schemas.openxmlformats.org/drawingml/2006/main">
               <a:ext uri="{FF2B5EF4-FFF2-40B4-BE49-F238E27FC236}">
-                <a16:creationId xmlns:a16="http://schemas.microsoft.com/office/drawing/2014/main" id="{480B5915-12D5-4C7A-8823-3C3B0F937ED3}"/>
+                <a16:creationId xmlns:a16="http://schemas.microsoft.com/office/drawing/2014/main" id="{B4FBF4D4-956A-4C0E-87BC-634C72A714C6}"/>
               </a:ext>
             </a:extLst>
           </p:cNvPr>
@@ -4629,7 +4629,7 @@
           <p:nvPr/>
         </p:nvPicPr>
         <p:blipFill>
-          <a:blip xmlns:r="http://schemas.openxmlformats.org/officeDocument/2006/relationships" xmlns:a="http://schemas.openxmlformats.org/drawingml/2006/main" r:embed="R41f8988223b34496"/>
+          <a:blip xmlns:r="http://schemas.openxmlformats.org/officeDocument/2006/relationships" xmlns:a="http://schemas.openxmlformats.org/drawingml/2006/main" r:embed="R94db71036e994401"/>
           <a:stretch xmlns:a="http://schemas.openxmlformats.org/drawingml/2006/main"/>
         </p:blipFill>
         <p:spPr>
@@ -4647,7 +4647,7 @@
           <p:cNvPr id="64" name="">
             <a:extLst xmlns:a="http://schemas.openxmlformats.org/drawingml/2006/main">
               <a:ext uri="{FF2B5EF4-FFF2-40B4-BE49-F238E27FC236}">
-                <a16:creationId xmlns:a16="http://schemas.microsoft.com/office/drawing/2014/main" id="{287BCD90-1509-4279-9842-DBE55A6ED1B6}"/>
+                <a16:creationId xmlns:a16="http://schemas.microsoft.com/office/drawing/2014/main" id="{14942EE3-D67F-4EC8-A3FB-1038B0362DCE}"/>
               </a:ext>
             </a:extLst>
           </p:cNvPr>
@@ -4657,7 +4657,7 @@
           <p:nvPr/>
         </p:nvPicPr>
         <p:blipFill>
-          <a:blip xmlns:r="http://schemas.openxmlformats.org/officeDocument/2006/relationships" xmlns:a="http://schemas.openxmlformats.org/drawingml/2006/main" r:embed="R18ec70d733c4423c"/>
+          <a:blip xmlns:r="http://schemas.openxmlformats.org/officeDocument/2006/relationships" xmlns:a="http://schemas.openxmlformats.org/drawingml/2006/main" r:embed="Rd010f2cc44554df3"/>
           <a:stretch xmlns:a="http://schemas.openxmlformats.org/drawingml/2006/main"/>
         </p:blipFill>
         <p:spPr>
@@ -4675,7 +4675,7 @@
           <p:cNvPr id="65" name="">
             <a:extLst xmlns:a="http://schemas.openxmlformats.org/drawingml/2006/main">
               <a:ext uri="{FF2B5EF4-FFF2-40B4-BE49-F238E27FC236}">
-                <a16:creationId xmlns:a16="http://schemas.microsoft.com/office/drawing/2014/main" id="{A301D324-A0B1-4305-B77E-66C5942FF3BC}"/>
+                <a16:creationId xmlns:a16="http://schemas.microsoft.com/office/drawing/2014/main" id="{E8C81A74-3DB1-4463-A34E-287AFB442882}"/>
               </a:ext>
             </a:extLst>
           </p:cNvPr>
@@ -4685,7 +4685,7 @@
           <p:nvPr/>
         </p:nvPicPr>
         <p:blipFill>
-          <a:blip xmlns:r="http://schemas.openxmlformats.org/officeDocument/2006/relationships" xmlns:a="http://schemas.openxmlformats.org/drawingml/2006/main" r:embed="Rb55c47e584ae4518"/>
+          <a:blip xmlns:r="http://schemas.openxmlformats.org/officeDocument/2006/relationships" xmlns:a="http://schemas.openxmlformats.org/drawingml/2006/main" r:embed="Rc9b0a990475d42dd"/>
           <a:stretch xmlns:a="http://schemas.openxmlformats.org/drawingml/2006/main"/>
         </p:blipFill>
         <p:spPr>
@@ -4703,7 +4703,7 @@
           <p:cNvPr id="66" name="">
             <a:extLst xmlns:a="http://schemas.openxmlformats.org/drawingml/2006/main">
               <a:ext uri="{FF2B5EF4-FFF2-40B4-BE49-F238E27FC236}">
-                <a16:creationId xmlns:a16="http://schemas.microsoft.com/office/drawing/2014/main" id="{CD9DCA2C-570C-48D7-B105-714684D8415B}"/>
+                <a16:creationId xmlns:a16="http://schemas.microsoft.com/office/drawing/2014/main" id="{A89A370E-F635-47EE-87CF-A9D3C4350BE5}"/>
               </a:ext>
             </a:extLst>
           </p:cNvPr>
@@ -4767,7 +4767,7 @@
           <p:cNvPr id="67" name="">
             <a:extLst xmlns:a="http://schemas.openxmlformats.org/drawingml/2006/main">
               <a:ext uri="{FF2B5EF4-FFF2-40B4-BE49-F238E27FC236}">
-                <a16:creationId xmlns:a16="http://schemas.microsoft.com/office/drawing/2014/main" id="{30F975CE-631F-4563-824E-3301328ADA87}"/>
+                <a16:creationId xmlns:a16="http://schemas.microsoft.com/office/drawing/2014/main" id="{EF49D12B-28CE-47F6-82B4-9435BD6ADFED}"/>
               </a:ext>
             </a:extLst>
           </p:cNvPr>
@@ -4831,7 +4831,7 @@
           <p:cNvPr id="68" name="">
             <a:extLst xmlns:a="http://schemas.openxmlformats.org/drawingml/2006/main">
               <a:ext uri="{FF2B5EF4-FFF2-40B4-BE49-F238E27FC236}">
-                <a16:creationId xmlns:a16="http://schemas.microsoft.com/office/drawing/2014/main" id="{3DF4F341-E340-4643-A999-7C41433C3573}"/>
+                <a16:creationId xmlns:a16="http://schemas.microsoft.com/office/drawing/2014/main" id="{58FC338D-7E65-465E-88D7-DDC89DF50D9F}"/>
               </a:ext>
             </a:extLst>
           </p:cNvPr>
@@ -4895,7 +4895,7 @@
           <p:cNvPr id="69" name="">
             <a:extLst xmlns:a="http://schemas.openxmlformats.org/drawingml/2006/main">
               <a:ext uri="{FF2B5EF4-FFF2-40B4-BE49-F238E27FC236}">
-                <a16:creationId xmlns:a16="http://schemas.microsoft.com/office/drawing/2014/main" id="{6AE4C14E-3334-4DBA-B7B1-3B57E99B7CFF}"/>
+                <a16:creationId xmlns:a16="http://schemas.microsoft.com/office/drawing/2014/main" id="{28776E84-2AB5-4C89-8D8B-D5921929FC17}"/>
               </a:ext>
             </a:extLst>
           </p:cNvPr>

</xml_diff>